<commit_message>
Record full-context blank-canvas results
Preserve all Experiment 013 prompts and generations, document the 8/9 tie with the concise direct-prompt baseline, and rebuild the presentation, poster, report, and answers from raw evidence.

Co-authored-by: Copilot <223556219+Copilot@users.noreply.github.com>
Copilot-Session: 5378916b-a421-4d1f-a92b-6653bb48491b
</commit_message>
<xml_diff>
--- a/deliverables/presentation.pptx
+++ b/deliverables/presentation.pptx
@@ -27,6 +27,7 @@
     <p:sldId id="275" r:id="rId26"/>
     <p:sldId id="276" r:id="rId27"/>
     <p:sldId id="277" r:id="rId28"/>
+    <p:sldId id="278" r:id="rId29"/>
   </p:sldIdLst>
   <p:sldSz cx="12191695" cy="6858000" type="screen4x3"/>
   <p:notesSz cx="6858000" cy="9144000"/>
@@ -8063,7 +8064,7 @@
               </a:defRPr>
             </a:pPr>
             <a:r>
-              <a:t>Aggregate endpoint-valid result across four workloads</a:t>
+              <a:t>Experiment 013: all parent context in the prompt, blank canvas</a:t>
             </a:r>
           </a:p>
         </p:txBody>
@@ -8111,40 +8112,16 @@
           </a:p>
         </p:txBody>
       </p:sp>
-      <p:pic>
-        <p:nvPicPr>
-          <p:cNvPr id="4" name="Picture 3" descr="Stacked bars compare zero of 42 hybrids from numerical representation methods with 17 of 18 strict hybrids from direct diffusion prompting."/>
-          <p:cNvPicPr>
-            <a:picLocks noChangeAspect="1"/>
-          </p:cNvPicPr>
-          <p:nvPr/>
-        </p:nvPicPr>
-        <p:blipFill>
-          <a:blip r:embed="rId2"/>
-          <a:stretch>
-            <a:fillRect/>
-          </a:stretch>
-        </p:blipFill>
-        <p:spPr>
-          <a:xfrm>
-            <a:off x="594360" y="1280160"/>
-            <a:ext cx="6492240" cy="4389120"/>
-          </a:xfrm>
-          <a:prstGeom prst="rect">
-            <a:avLst/>
-          </a:prstGeom>
-        </p:spPr>
-      </p:pic>
-      <p:sp>
-        <p:nvSpPr>
-          <p:cNvPr id="5" name="Rounded Rectangle 4"/>
+      <p:sp>
+        <p:nvSpPr>
+          <p:cNvPr id="4" name="Rounded Rectangle 3"/>
           <p:cNvSpPr/>
           <p:nvPr/>
         </p:nvSpPr>
         <p:spPr>
           <a:xfrm>
-            <a:off x="7406640" y="1417320"/>
-            <a:ext cx="3977639" cy="1463040"/>
+            <a:off x="502920" y="1280160"/>
+            <a:ext cx="3520440" cy="4297680"/>
           </a:xfrm>
           <a:prstGeom prst="roundRect">
             <a:avLst/>
@@ -8182,20 +8159,20 @@
       </p:sp>
       <p:sp>
         <p:nvSpPr>
-          <p:cNvPr id="6" name="Rectangle 5"/>
+          <p:cNvPr id="5" name="Rectangle 4"/>
           <p:cNvSpPr/>
           <p:nvPr/>
         </p:nvSpPr>
         <p:spPr>
           <a:xfrm>
-            <a:off x="7406640" y="1417320"/>
-            <a:ext cx="91440" cy="1463040"/>
+            <a:off x="502920" y="1280160"/>
+            <a:ext cx="91440" cy="4297680"/>
           </a:xfrm>
           <a:prstGeom prst="rect">
             <a:avLst/>
           </a:prstGeom>
           <a:solidFill>
-            <a:srgbClr val="B91C1C"/>
+            <a:srgbClr val="2563EB"/>
           </a:solidFill>
           <a:ln>
             <a:noFill/>
@@ -8225,14 +8202,14 @@
       </p:sp>
       <p:sp>
         <p:nvSpPr>
-          <p:cNvPr id="7" name="TextBox 6"/>
-          <p:cNvSpPr txBox="1"/>
-          <p:nvPr/>
-        </p:nvSpPr>
-        <p:spPr>
-          <a:xfrm>
-            <a:off x="7607808" y="1563624"/>
-            <a:ext cx="3657599" cy="384048"/>
+          <p:cNvPr id="6" name="TextBox 5"/>
+          <p:cNvSpPr txBox="1"/>
+          <p:nvPr/>
+        </p:nvSpPr>
+        <p:spPr>
+          <a:xfrm>
+            <a:off x="704088" y="1426463"/>
+            <a:ext cx="3200400" cy="384048"/>
           </a:xfrm>
           <a:prstGeom prst="rect">
             <a:avLst/>
@@ -8254,21 +8231,21 @@
               </a:defRPr>
             </a:pPr>
             <a:r>
-              <a:t>Numerical representation methods</a:t>
-            </a:r>
-          </a:p>
-        </p:txBody>
-      </p:sp>
-      <p:sp>
-        <p:nvSpPr>
-          <p:cNvPr id="8" name="TextBox 7"/>
-          <p:cNvSpPr txBox="1"/>
-          <p:nvPr/>
-        </p:nvSpPr>
-        <p:spPr>
-          <a:xfrm>
-            <a:off x="7607808" y="2011680"/>
-            <a:ext cx="3630168" cy="731520"/>
+              <a:t>Prompt-only configuration</a:t>
+            </a:r>
+          </a:p>
+        </p:txBody>
+      </p:sp>
+      <p:sp>
+        <p:nvSpPr>
+          <p:cNvPr id="7" name="TextBox 6"/>
+          <p:cNvSpPr txBox="1"/>
+          <p:nvPr/>
+        </p:nvSpPr>
+        <p:spPr>
+          <a:xfrm>
+            <a:off x="704088" y="1874519"/>
+            <a:ext cx="3172968" cy="3566160"/>
           </a:xfrm>
           <a:prstGeom prst="rect">
             <a:avLst/>
@@ -8290,21 +8267,26 @@
               </a:defRPr>
             </a:pPr>
             <a:r>
-              <a:t>0/42 candidate hybrids.</a:t>
-            </a:r>
-          </a:p>
-        </p:txBody>
-      </p:sp>
-      <p:sp>
-        <p:nvSpPr>
-          <p:cNvPr id="9" name="Rounded Rectangle 8"/>
+              <a:t>Both complete frozen parent records were placed in one prompt.</a:t>
+            </a:r>
+            <a:br/>
+            <a:br/>
+            <a:r>
+              <a:t>No parent embedding, hidden state, token canvas, or logits were supplied.</a:t>
+            </a:r>
+          </a:p>
+        </p:txBody>
+      </p:sp>
+      <p:sp>
+        <p:nvSpPr>
+          <p:cNvPr id="8" name="Rounded Rectangle 7"/>
           <p:cNvSpPr/>
           <p:nvPr/>
         </p:nvSpPr>
         <p:spPr>
           <a:xfrm>
-            <a:off x="7406640" y="3154680"/>
-            <a:ext cx="3977639" cy="1463040"/>
+            <a:off x="4334256" y="1280160"/>
+            <a:ext cx="3520440" cy="4297680"/>
           </a:xfrm>
           <a:prstGeom prst="roundRect">
             <a:avLst/>
@@ -8342,14 +8324,14 @@
       </p:sp>
       <p:sp>
         <p:nvSpPr>
-          <p:cNvPr id="10" name="Rectangle 9"/>
+          <p:cNvPr id="9" name="Rectangle 8"/>
           <p:cNvSpPr/>
           <p:nvPr/>
         </p:nvSpPr>
         <p:spPr>
           <a:xfrm>
-            <a:off x="7406640" y="3154680"/>
-            <a:ext cx="91440" cy="1463040"/>
+            <a:off x="4334256" y="1280160"/>
+            <a:ext cx="91440" cy="4297680"/>
           </a:xfrm>
           <a:prstGeom prst="rect">
             <a:avLst/>
@@ -8385,14 +8367,14 @@
       </p:sp>
       <p:sp>
         <p:nvSpPr>
-          <p:cNvPr id="11" name="TextBox 10"/>
-          <p:cNvSpPr txBox="1"/>
-          <p:nvPr/>
-        </p:nvSpPr>
-        <p:spPr>
-          <a:xfrm>
-            <a:off x="7607808" y="3300984"/>
-            <a:ext cx="3657599" cy="384048"/>
+          <p:cNvPr id="10" name="TextBox 9"/>
+          <p:cNvSpPr txBox="1"/>
+          <p:nvPr/>
+        </p:nvSpPr>
+        <p:spPr>
+          <a:xfrm>
+            <a:off x="4535424" y="1426463"/>
+            <a:ext cx="3200400" cy="384048"/>
           </a:xfrm>
           <a:prstGeom prst="rect">
             <a:avLst/>
@@ -8414,21 +8396,21 @@
               </a:defRPr>
             </a:pPr>
             <a:r>
-              <a:t>Direct diffusion prompting</a:t>
-            </a:r>
-          </a:p>
-        </p:txBody>
-      </p:sp>
-      <p:sp>
-        <p:nvSpPr>
-          <p:cNvPr id="12" name="TextBox 11"/>
-          <p:cNvSpPr txBox="1"/>
-          <p:nvPr/>
-        </p:nvSpPr>
-        <p:spPr>
-          <a:xfrm>
-            <a:off x="7607808" y="3749040"/>
-            <a:ext cx="3630168" cy="731520"/>
+              <a:t>Strict aggregate</a:t>
+            </a:r>
+          </a:p>
+        </p:txBody>
+      </p:sp>
+      <p:sp>
+        <p:nvSpPr>
+          <p:cNvPr id="11" name="TextBox 10"/>
+          <p:cNvSpPr txBox="1"/>
+          <p:nvPr/>
+        </p:nvSpPr>
+        <p:spPr>
+          <a:xfrm>
+            <a:off x="4535424" y="1874519"/>
+            <a:ext cx="3172968" cy="3566160"/>
           </a:xfrm>
           <a:prstGeom prst="rect">
             <a:avLst/>
@@ -8450,21 +8432,203 @@
               </a:defRPr>
             </a:pPr>
             <a:r>
-              <a:t>17/18 strict candidate hybrids.</a:t>
-            </a:r>
-          </a:p>
-        </p:txBody>
-      </p:sp>
-      <p:sp>
-        <p:nvSpPr>
-          <p:cNvPr id="13" name="TextBox 12"/>
-          <p:cNvSpPr txBox="1"/>
-          <p:nvPr/>
-        </p:nvSpPr>
-        <p:spPr>
-          <a:xfrm>
-            <a:off x="7498079" y="5074920"/>
-            <a:ext cx="3749039" cy="457200"/>
+              <a:t>Full context: 8/9</a:t>
+            </a:r>
+            <a:br/>
+            <a:r>
+              <a:t>Concise baseline: 8/9</a:t>
+            </a:r>
+            <a:br/>
+            <a:br/>
+            <a:r>
+              <a:t>Aggregate improvement: none.</a:t>
+            </a:r>
+          </a:p>
+        </p:txBody>
+      </p:sp>
+      <p:sp>
+        <p:nvSpPr>
+          <p:cNvPr id="12" name="Rounded Rectangle 11"/>
+          <p:cNvSpPr/>
+          <p:nvPr/>
+        </p:nvSpPr>
+        <p:spPr>
+          <a:xfrm>
+            <a:off x="8165592" y="1280160"/>
+            <a:ext cx="3520440" cy="4297680"/>
+          </a:xfrm>
+          <a:prstGeom prst="roundRect">
+            <a:avLst/>
+          </a:prstGeom>
+          <a:solidFill>
+            <a:srgbClr val="FFFFFF"/>
+          </a:solidFill>
+          <a:ln>
+            <a:solidFill>
+              <a:srgbClr val="D8E1EE"/>
+            </a:solidFill>
+          </a:ln>
+        </p:spPr>
+        <p:style>
+          <a:lnRef idx="1">
+            <a:schemeClr val="accent1"/>
+          </a:lnRef>
+          <a:fillRef idx="3">
+            <a:schemeClr val="accent1"/>
+          </a:fillRef>
+          <a:effectRef idx="2">
+            <a:schemeClr val="accent1"/>
+          </a:effectRef>
+          <a:fontRef idx="minor">
+            <a:schemeClr val="lt1"/>
+          </a:fontRef>
+        </p:style>
+        <p:txBody>
+          <a:bodyPr rtlCol="0" anchor="ctr"/>
+          <a:lstStyle/>
+          <a:p>
+            <a:pPr algn="ctr"/>
+          </a:p>
+        </p:txBody>
+      </p:sp>
+      <p:sp>
+        <p:nvSpPr>
+          <p:cNvPr id="13" name="Rectangle 12"/>
+          <p:cNvSpPr/>
+          <p:nvPr/>
+        </p:nvSpPr>
+        <p:spPr>
+          <a:xfrm>
+            <a:off x="8165592" y="1280160"/>
+            <a:ext cx="91440" cy="4297680"/>
+          </a:xfrm>
+          <a:prstGeom prst="rect">
+            <a:avLst/>
+          </a:prstGeom>
+          <a:solidFill>
+            <a:srgbClr val="7C3AED"/>
+          </a:solidFill>
+          <a:ln>
+            <a:noFill/>
+          </a:ln>
+        </p:spPr>
+        <p:style>
+          <a:lnRef idx="1">
+            <a:schemeClr val="accent1"/>
+          </a:lnRef>
+          <a:fillRef idx="3">
+            <a:schemeClr val="accent1"/>
+          </a:fillRef>
+          <a:effectRef idx="2">
+            <a:schemeClr val="accent1"/>
+          </a:effectRef>
+          <a:fontRef idx="minor">
+            <a:schemeClr val="lt1"/>
+          </a:fontRef>
+        </p:style>
+        <p:txBody>
+          <a:bodyPr rtlCol="0" anchor="ctr"/>
+          <a:lstStyle/>
+          <a:p>
+            <a:pPr algn="ctr"/>
+          </a:p>
+        </p:txBody>
+      </p:sp>
+      <p:sp>
+        <p:nvSpPr>
+          <p:cNvPr id="14" name="TextBox 13"/>
+          <p:cNvSpPr txBox="1"/>
+          <p:nvPr/>
+        </p:nvSpPr>
+        <p:spPr>
+          <a:xfrm>
+            <a:off x="8366760" y="1426463"/>
+            <a:ext cx="3200400" cy="384048"/>
+          </a:xfrm>
+          <a:prstGeom prst="rect">
+            <a:avLst/>
+          </a:prstGeom>
+          <a:noFill/>
+        </p:spPr>
+        <p:txBody>
+          <a:bodyPr wrap="square" anchor="t">
+            <a:spAutoFit/>
+          </a:bodyPr>
+          <a:lstStyle/>
+          <a:p>
+            <a:pPr algn="l">
+              <a:defRPr sz="1700" b="1">
+                <a:solidFill>
+                  <a:srgbClr val="102A43"/>
+                </a:solidFill>
+                <a:latin typeface="Aptos"/>
+              </a:defRPr>
+            </a:pPr>
+            <a:r>
+              <a:t>Pair-level shift</a:t>
+            </a:r>
+          </a:p>
+        </p:txBody>
+      </p:sp>
+      <p:sp>
+        <p:nvSpPr>
+          <p:cNvPr id="15" name="TextBox 14"/>
+          <p:cNvSpPr txBox="1"/>
+          <p:nvPr/>
+        </p:nvSpPr>
+        <p:spPr>
+          <a:xfrm>
+            <a:off x="8366760" y="1874519"/>
+            <a:ext cx="3172968" cy="3566160"/>
+          </a:xfrm>
+          <a:prstGeom prst="rect">
+            <a:avLst/>
+          </a:prstGeom>
+          <a:noFill/>
+        </p:spPr>
+        <p:txBody>
+          <a:bodyPr wrap="square" anchor="t">
+            <a:spAutoFit/>
+          </a:bodyPr>
+          <a:lstStyle/>
+          <a:p>
+            <a:pPr algn="l">
+              <a:defRPr sz="1400" b="0">
+                <a:solidFill>
+                  <a:srgbClr val="0F172A"/>
+                </a:solidFill>
+                <a:latin typeface="Aptos"/>
+              </a:defRPr>
+            </a:pPr>
+            <a:r>
+              <a:t>Matrix: 3/3</a:t>
+            </a:r>
+            <a:br/>
+            <a:r>
+              <a:t>Graph: 3/3</a:t>
+            </a:r>
+            <a:br/>
+            <a:r>
+              <a:t>Image: 2/3</a:t>
+            </a:r>
+            <a:br/>
+            <a:br/>
+            <a:r>
+              <a:t>The image failure omitted output order but retained vectorization and batching.</a:t>
+            </a:r>
+          </a:p>
+        </p:txBody>
+      </p:sp>
+      <p:sp>
+        <p:nvSpPr>
+          <p:cNvPr id="16" name="TextBox 15"/>
+          <p:cNvSpPr txBox="1"/>
+          <p:nvPr/>
+        </p:nvSpPr>
+        <p:spPr>
+          <a:xfrm>
+            <a:off x="731520" y="5715000"/>
+            <a:ext cx="10698480" cy="502920"/>
           </a:xfrm>
           <a:prstGeom prst="rect">
             <a:avLst/>
@@ -8478,22 +8642,22 @@
           <a:lstStyle/>
           <a:p>
             <a:pPr algn="ctr">
-              <a:defRPr sz="1600" b="1">
-                <a:solidFill>
-                  <a:srgbClr val="64748B"/>
-                </a:solidFill>
-                <a:latin typeface="Aptos"/>
-              </a:defRPr>
-            </a:pPr>
-            <a:r>
-              <a:t>Pilot contrast—not a population estimate.</a:t>
-            </a:r>
-          </a:p>
-        </p:txBody>
-      </p:sp>
-      <p:sp>
-        <p:nvSpPr>
-          <p:cNvPr id="14" name="TextBox 13"/>
+              <a:defRPr sz="1800" b="1">
+                <a:solidFill>
+                  <a:srgbClr val="102A43"/>
+                </a:solidFill>
+                <a:latin typeface="Aptos"/>
+              </a:defRPr>
+            </a:pPr>
+            <a:r>
+              <a:t>Result: Sergiy's blank-canvas prompt-only approach works reliably, but the longer context did not outperform the concise explicit prompt.</a:t>
+            </a:r>
+          </a:p>
+        </p:txBody>
+      </p:sp>
+      <p:sp>
+        <p:nvSpPr>
+          <p:cNvPr id="17" name="TextBox 16"/>
           <p:cNvSpPr txBox="1"/>
           <p:nvPr/>
         </p:nvSpPr>
@@ -8522,7 +8686,7 @@
               </a:defRPr>
             </a:pPr>
             <a:r>
-              <a:t>Pilot evidence • September 18, 2026 • experiments/008/results/results.json | experiments/009/results/results.json | experiments/012/results/results.json</a:t>
+              <a:t>Pilot evidence • September 18, 2026 • experiments/013-full-context-blank-canvas/results/results.json | experiments/013-full-context-blank-canvas/results/assessment.md</a:t>
             </a:r>
           </a:p>
         </p:txBody>
@@ -8584,7 +8748,7 @@
               </a:defRPr>
             </a:pPr>
             <a:r>
-              <a:t>What actually succeeded?</a:t>
+              <a:t>Aggregate endpoint-valid result across four workloads</a:t>
             </a:r>
           </a:p>
         </p:txBody>
@@ -8632,33 +8796,178 @@
           </a:p>
         </p:txBody>
       </p:sp>
-      <p:sp>
-        <p:nvSpPr>
-          <p:cNvPr id="4" name="TextBox 3"/>
-          <p:cNvSpPr txBox="1"/>
-          <p:nvPr/>
-        </p:nvSpPr>
-        <p:spPr>
-          <a:xfrm>
-            <a:off x="914400" y="1280160"/>
-            <a:ext cx="10424160" cy="4937760"/>
-          </a:xfrm>
-          <a:prstGeom prst="rect">
-            <a:avLst/>
-          </a:prstGeom>
-          <a:noFill/>
-        </p:spPr>
-        <p:txBody>
-          <a:bodyPr wrap="square">
-            <a:spAutoFit/>
-          </a:bodyPr>
-          <a:lstStyle/>
-          <a:p>
-            <a:pPr>
-              <a:spcAft>
-                <a:spcPts val="1000"/>
-              </a:spcAft>
-              <a:defRPr sz="2100">
+      <p:pic>
+        <p:nvPicPr>
+          <p:cNvPr id="4" name="Picture 3" descr="Stacked bars compare zero of 42 hybrids from numerical representation methods with 17 of 18 strict hybrids from direct diffusion prompting."/>
+          <p:cNvPicPr>
+            <a:picLocks noChangeAspect="1"/>
+          </p:cNvPicPr>
+          <p:nvPr/>
+        </p:nvPicPr>
+        <p:blipFill>
+          <a:blip r:embed="rId2"/>
+          <a:stretch>
+            <a:fillRect/>
+          </a:stretch>
+        </p:blipFill>
+        <p:spPr>
+          <a:xfrm>
+            <a:off x="594360" y="1280160"/>
+            <a:ext cx="6492240" cy="4389120"/>
+          </a:xfrm>
+          <a:prstGeom prst="rect">
+            <a:avLst/>
+          </a:prstGeom>
+        </p:spPr>
+      </p:pic>
+      <p:sp>
+        <p:nvSpPr>
+          <p:cNvPr id="5" name="Rounded Rectangle 4"/>
+          <p:cNvSpPr/>
+          <p:nvPr/>
+        </p:nvSpPr>
+        <p:spPr>
+          <a:xfrm>
+            <a:off x="7406640" y="1417320"/>
+            <a:ext cx="3977639" cy="1463040"/>
+          </a:xfrm>
+          <a:prstGeom prst="roundRect">
+            <a:avLst/>
+          </a:prstGeom>
+          <a:solidFill>
+            <a:srgbClr val="FFFFFF"/>
+          </a:solidFill>
+          <a:ln>
+            <a:solidFill>
+              <a:srgbClr val="D8E1EE"/>
+            </a:solidFill>
+          </a:ln>
+        </p:spPr>
+        <p:style>
+          <a:lnRef idx="1">
+            <a:schemeClr val="accent1"/>
+          </a:lnRef>
+          <a:fillRef idx="3">
+            <a:schemeClr val="accent1"/>
+          </a:fillRef>
+          <a:effectRef idx="2">
+            <a:schemeClr val="accent1"/>
+          </a:effectRef>
+          <a:fontRef idx="minor">
+            <a:schemeClr val="lt1"/>
+          </a:fontRef>
+        </p:style>
+        <p:txBody>
+          <a:bodyPr rtlCol="0" anchor="ctr"/>
+          <a:lstStyle/>
+          <a:p>
+            <a:pPr algn="ctr"/>
+          </a:p>
+        </p:txBody>
+      </p:sp>
+      <p:sp>
+        <p:nvSpPr>
+          <p:cNvPr id="6" name="Rectangle 5"/>
+          <p:cNvSpPr/>
+          <p:nvPr/>
+        </p:nvSpPr>
+        <p:spPr>
+          <a:xfrm>
+            <a:off x="7406640" y="1417320"/>
+            <a:ext cx="91440" cy="1463040"/>
+          </a:xfrm>
+          <a:prstGeom prst="rect">
+            <a:avLst/>
+          </a:prstGeom>
+          <a:solidFill>
+            <a:srgbClr val="B91C1C"/>
+          </a:solidFill>
+          <a:ln>
+            <a:noFill/>
+          </a:ln>
+        </p:spPr>
+        <p:style>
+          <a:lnRef idx="1">
+            <a:schemeClr val="accent1"/>
+          </a:lnRef>
+          <a:fillRef idx="3">
+            <a:schemeClr val="accent1"/>
+          </a:fillRef>
+          <a:effectRef idx="2">
+            <a:schemeClr val="accent1"/>
+          </a:effectRef>
+          <a:fontRef idx="minor">
+            <a:schemeClr val="lt1"/>
+          </a:fontRef>
+        </p:style>
+        <p:txBody>
+          <a:bodyPr rtlCol="0" anchor="ctr"/>
+          <a:lstStyle/>
+          <a:p>
+            <a:pPr algn="ctr"/>
+          </a:p>
+        </p:txBody>
+      </p:sp>
+      <p:sp>
+        <p:nvSpPr>
+          <p:cNvPr id="7" name="TextBox 6"/>
+          <p:cNvSpPr txBox="1"/>
+          <p:nvPr/>
+        </p:nvSpPr>
+        <p:spPr>
+          <a:xfrm>
+            <a:off x="7607808" y="1563624"/>
+            <a:ext cx="3657599" cy="384048"/>
+          </a:xfrm>
+          <a:prstGeom prst="rect">
+            <a:avLst/>
+          </a:prstGeom>
+          <a:noFill/>
+        </p:spPr>
+        <p:txBody>
+          <a:bodyPr wrap="square" anchor="t">
+            <a:spAutoFit/>
+          </a:bodyPr>
+          <a:lstStyle/>
+          <a:p>
+            <a:pPr algn="l">
+              <a:defRPr sz="1700" b="1">
+                <a:solidFill>
+                  <a:srgbClr val="102A43"/>
+                </a:solidFill>
+                <a:latin typeface="Aptos"/>
+              </a:defRPr>
+            </a:pPr>
+            <a:r>
+              <a:t>Numerical representation methods</a:t>
+            </a:r>
+          </a:p>
+        </p:txBody>
+      </p:sp>
+      <p:sp>
+        <p:nvSpPr>
+          <p:cNvPr id="8" name="TextBox 7"/>
+          <p:cNvSpPr txBox="1"/>
+          <p:nvPr/>
+        </p:nvSpPr>
+        <p:spPr>
+          <a:xfrm>
+            <a:off x="7607808" y="2011680"/>
+            <a:ext cx="3630168" cy="731520"/>
+          </a:xfrm>
+          <a:prstGeom prst="rect">
+            <a:avLst/>
+          </a:prstGeom>
+          <a:noFill/>
+        </p:spPr>
+        <p:txBody>
+          <a:bodyPr wrap="square" anchor="t">
+            <a:spAutoFit/>
+          </a:bodyPr>
+          <a:lstStyle/>
+          <a:p>
+            <a:pPr algn="l">
+              <a:defRPr sz="1400" b="0">
                 <a:solidFill>
                   <a:srgbClr val="0F172A"/>
                 </a:solidFill>
@@ -8666,15 +8975,159 @@
               </a:defRPr>
             </a:pPr>
             <a:r>
-              <a:t>Reproducible full-model execution with seeds, hashes, revisions, timings, and preserved raw outputs.</a:t>
-            </a:r>
-          </a:p>
-          <a:p>
-            <a:pPr>
-              <a:spcAft>
-                <a:spcPts val="1000"/>
-              </a:spcAft>
-              <a:defRPr sz="2100">
+              <a:t>0/42 candidate hybrids.</a:t>
+            </a:r>
+          </a:p>
+        </p:txBody>
+      </p:sp>
+      <p:sp>
+        <p:nvSpPr>
+          <p:cNvPr id="9" name="Rounded Rectangle 8"/>
+          <p:cNvSpPr/>
+          <p:nvPr/>
+        </p:nvSpPr>
+        <p:spPr>
+          <a:xfrm>
+            <a:off x="7406640" y="3154680"/>
+            <a:ext cx="3977639" cy="1463040"/>
+          </a:xfrm>
+          <a:prstGeom prst="roundRect">
+            <a:avLst/>
+          </a:prstGeom>
+          <a:solidFill>
+            <a:srgbClr val="FFFFFF"/>
+          </a:solidFill>
+          <a:ln>
+            <a:solidFill>
+              <a:srgbClr val="D8E1EE"/>
+            </a:solidFill>
+          </a:ln>
+        </p:spPr>
+        <p:style>
+          <a:lnRef idx="1">
+            <a:schemeClr val="accent1"/>
+          </a:lnRef>
+          <a:fillRef idx="3">
+            <a:schemeClr val="accent1"/>
+          </a:fillRef>
+          <a:effectRef idx="2">
+            <a:schemeClr val="accent1"/>
+          </a:effectRef>
+          <a:fontRef idx="minor">
+            <a:schemeClr val="lt1"/>
+          </a:fontRef>
+        </p:style>
+        <p:txBody>
+          <a:bodyPr rtlCol="0" anchor="ctr"/>
+          <a:lstStyle/>
+          <a:p>
+            <a:pPr algn="ctr"/>
+          </a:p>
+        </p:txBody>
+      </p:sp>
+      <p:sp>
+        <p:nvSpPr>
+          <p:cNvPr id="10" name="Rectangle 9"/>
+          <p:cNvSpPr/>
+          <p:nvPr/>
+        </p:nvSpPr>
+        <p:spPr>
+          <a:xfrm>
+            <a:off x="7406640" y="3154680"/>
+            <a:ext cx="91440" cy="1463040"/>
+          </a:xfrm>
+          <a:prstGeom prst="rect">
+            <a:avLst/>
+          </a:prstGeom>
+          <a:solidFill>
+            <a:srgbClr val="15803D"/>
+          </a:solidFill>
+          <a:ln>
+            <a:noFill/>
+          </a:ln>
+        </p:spPr>
+        <p:style>
+          <a:lnRef idx="1">
+            <a:schemeClr val="accent1"/>
+          </a:lnRef>
+          <a:fillRef idx="3">
+            <a:schemeClr val="accent1"/>
+          </a:fillRef>
+          <a:effectRef idx="2">
+            <a:schemeClr val="accent1"/>
+          </a:effectRef>
+          <a:fontRef idx="minor">
+            <a:schemeClr val="lt1"/>
+          </a:fontRef>
+        </p:style>
+        <p:txBody>
+          <a:bodyPr rtlCol="0" anchor="ctr"/>
+          <a:lstStyle/>
+          <a:p>
+            <a:pPr algn="ctr"/>
+          </a:p>
+        </p:txBody>
+      </p:sp>
+      <p:sp>
+        <p:nvSpPr>
+          <p:cNvPr id="11" name="TextBox 10"/>
+          <p:cNvSpPr txBox="1"/>
+          <p:nvPr/>
+        </p:nvSpPr>
+        <p:spPr>
+          <a:xfrm>
+            <a:off x="7607808" y="3300984"/>
+            <a:ext cx="3657599" cy="384048"/>
+          </a:xfrm>
+          <a:prstGeom prst="rect">
+            <a:avLst/>
+          </a:prstGeom>
+          <a:noFill/>
+        </p:spPr>
+        <p:txBody>
+          <a:bodyPr wrap="square" anchor="t">
+            <a:spAutoFit/>
+          </a:bodyPr>
+          <a:lstStyle/>
+          <a:p>
+            <a:pPr algn="l">
+              <a:defRPr sz="1700" b="1">
+                <a:solidFill>
+                  <a:srgbClr val="102A43"/>
+                </a:solidFill>
+                <a:latin typeface="Aptos"/>
+              </a:defRPr>
+            </a:pPr>
+            <a:r>
+              <a:t>Direct diffusion prompting</a:t>
+            </a:r>
+          </a:p>
+        </p:txBody>
+      </p:sp>
+      <p:sp>
+        <p:nvSpPr>
+          <p:cNvPr id="12" name="TextBox 11"/>
+          <p:cNvSpPr txBox="1"/>
+          <p:nvPr/>
+        </p:nvSpPr>
+        <p:spPr>
+          <a:xfrm>
+            <a:off x="7607808" y="3749040"/>
+            <a:ext cx="3630168" cy="731520"/>
+          </a:xfrm>
+          <a:prstGeom prst="rect">
+            <a:avLst/>
+          </a:prstGeom>
+          <a:noFill/>
+        </p:spPr>
+        <p:txBody>
+          <a:bodyPr wrap="square" anchor="t">
+            <a:spAutoFit/>
+          </a:bodyPr>
+          <a:lstStyle/>
+          <a:p>
+            <a:pPr algn="l">
+              <a:defRPr sz="1400" b="0">
                 <a:solidFill>
                   <a:srgbClr val="0F172A"/>
                 </a:solidFill>
@@ -8682,78 +9135,50 @@
               </a:defRPr>
             </a:pPr>
             <a:r>
-              <a:t>Endpoint decoding when prompts named the required implementation details.</a:t>
-            </a:r>
-          </a:p>
-          <a:p>
-            <a:pPr>
-              <a:spcAft>
-                <a:spcPts val="1000"/>
-              </a:spcAft>
-              <a:defRPr sz="2100">
-                <a:solidFill>
-                  <a:srgbClr val="0F172A"/>
-                </a:solidFill>
-                <a:latin typeface="Aptos"/>
-              </a:defRPr>
-            </a:pPr>
-            <a:r>
-              <a:t>A causal diagnostic: poor composition was not explained by simple vector cancellation.</a:t>
-            </a:r>
-          </a:p>
-          <a:p>
-            <a:pPr>
-              <a:spcAft>
-                <a:spcPts val="1000"/>
-              </a:spcAft>
-              <a:defRPr sz="2100">
-                <a:solidFill>
-                  <a:srgbClr val="0F172A"/>
-                </a:solidFill>
-                <a:latin typeface="Aptos"/>
-              </a:defRPr>
-            </a:pPr>
-            <a:r>
-              <a:t>A likely bottleneck: useful endpoint alternatives survived below top-1 but hard projection broke sequence-level meaning.</a:t>
-            </a:r>
-          </a:p>
-          <a:p>
-            <a:pPr>
-              <a:spcAft>
-                <a:spcPts val="1000"/>
-              </a:spcAft>
-              <a:defRPr sz="2100">
-                <a:solidFill>
-                  <a:srgbClr val="0F172A"/>
-                </a:solidFill>
-                <a:latin typeface="Aptos"/>
-              </a:defRPr>
-            </a:pPr>
-            <a:r>
-              <a:t>Direct diffusion prompting composed both parents 17/18 strict times across sorting, matrix, graph, and image pairs.</a:t>
-            </a:r>
-          </a:p>
-          <a:p>
-            <a:pPr>
-              <a:spcAft>
-                <a:spcPts val="1000"/>
-              </a:spcAft>
-              <a:defRPr sz="2100">
-                <a:solidFill>
-                  <a:srgbClr val="0F172A"/>
-                </a:solidFill>
-                <a:latin typeface="Aptos"/>
-              </a:defRPr>
-            </a:pPr>
-            <a:r>
-              <a:t>Endpoint gates prevented overinterpreting the blocked histogram and regex pairs.</a:t>
-            </a:r>
-          </a:p>
-        </p:txBody>
-      </p:sp>
-      <p:sp>
-        <p:nvSpPr>
-          <p:cNvPr id="5" name="TextBox 4"/>
+              <a:t>17/18 strict candidate hybrids.</a:t>
+            </a:r>
+          </a:p>
+        </p:txBody>
+      </p:sp>
+      <p:sp>
+        <p:nvSpPr>
+          <p:cNvPr id="13" name="TextBox 12"/>
+          <p:cNvSpPr txBox="1"/>
+          <p:nvPr/>
+        </p:nvSpPr>
+        <p:spPr>
+          <a:xfrm>
+            <a:off x="7498079" y="5074920"/>
+            <a:ext cx="3749039" cy="457200"/>
+          </a:xfrm>
+          <a:prstGeom prst="rect">
+            <a:avLst/>
+          </a:prstGeom>
+          <a:noFill/>
+        </p:spPr>
+        <p:txBody>
+          <a:bodyPr wrap="square" anchor="t">
+            <a:spAutoFit/>
+          </a:bodyPr>
+          <a:lstStyle/>
+          <a:p>
+            <a:pPr algn="ctr">
+              <a:defRPr sz="1600" b="1">
+                <a:solidFill>
+                  <a:srgbClr val="64748B"/>
+                </a:solidFill>
+                <a:latin typeface="Aptos"/>
+              </a:defRPr>
+            </a:pPr>
+            <a:r>
+              <a:t>Pilot contrast—not a population estimate.</a:t>
+            </a:r>
+          </a:p>
+        </p:txBody>
+      </p:sp>
+      <p:sp>
+        <p:nvSpPr>
+          <p:cNvPr id="14" name="TextBox 13"/>
           <p:cNvSpPr txBox="1"/>
           <p:nvPr/>
         </p:nvSpPr>
@@ -8782,7 +9207,7 @@
               </a:defRPr>
             </a:pPr>
             <a:r>
-              <a:t>Pilot evidence • September 18, 2026 • experiments/003–012/results/results.json</a:t>
+              <a:t>Pilot evidence • September 18, 2026 • experiments/008/results/results.json | experiments/009/results/results.json | experiments/012/results/results.json</a:t>
             </a:r>
           </a:p>
         </p:txBody>
@@ -8844,7 +9269,7 @@
               </a:defRPr>
             </a:pPr>
             <a:r>
-              <a:t>Sergiy’s explicit proposal: status of each item</a:t>
+              <a:t>What actually succeeded?</a:t>
             </a:r>
           </a:p>
         </p:txBody>
@@ -8894,152 +9319,31 @@
       </p:sp>
       <p:sp>
         <p:nvSpPr>
-          <p:cNvPr id="4" name="Rounded Rectangle 3"/>
-          <p:cNvSpPr/>
-          <p:nvPr/>
-        </p:nvSpPr>
-        <p:spPr>
-          <a:xfrm>
-            <a:off x="411480" y="1188720"/>
-            <a:ext cx="3474720" cy="1828800"/>
-          </a:xfrm>
-          <a:prstGeom prst="roundRect">
-            <a:avLst/>
-          </a:prstGeom>
-          <a:solidFill>
-            <a:srgbClr val="FFFFFF"/>
-          </a:solidFill>
-          <a:ln>
-            <a:solidFill>
-              <a:srgbClr val="D8E1EE"/>
-            </a:solidFill>
-          </a:ln>
-        </p:spPr>
-        <p:style>
-          <a:lnRef idx="1">
-            <a:schemeClr val="accent1"/>
-          </a:lnRef>
-          <a:fillRef idx="3">
-            <a:schemeClr val="accent1"/>
-          </a:fillRef>
-          <a:effectRef idx="2">
-            <a:schemeClr val="accent1"/>
-          </a:effectRef>
-          <a:fontRef idx="minor">
-            <a:schemeClr val="lt1"/>
-          </a:fontRef>
-        </p:style>
-        <p:txBody>
-          <a:bodyPr rtlCol="0" anchor="ctr"/>
-          <a:lstStyle/>
-          <a:p>
-            <a:pPr algn="ctr"/>
-          </a:p>
-        </p:txBody>
-      </p:sp>
-      <p:sp>
-        <p:nvSpPr>
-          <p:cNvPr id="5" name="Rectangle 4"/>
-          <p:cNvSpPr/>
-          <p:nvPr/>
-        </p:nvSpPr>
-        <p:spPr>
-          <a:xfrm>
-            <a:off x="411480" y="1188720"/>
-            <a:ext cx="91440" cy="1828800"/>
-          </a:xfrm>
-          <a:prstGeom prst="rect">
-            <a:avLst/>
-          </a:prstGeom>
-          <a:solidFill>
-            <a:srgbClr val="B91C1C"/>
-          </a:solidFill>
-          <a:ln>
-            <a:noFill/>
-          </a:ln>
-        </p:spPr>
-        <p:style>
-          <a:lnRef idx="1">
-            <a:schemeClr val="accent1"/>
-          </a:lnRef>
-          <a:fillRef idx="3">
-            <a:schemeClr val="accent1"/>
-          </a:fillRef>
-          <a:effectRef idx="2">
-            <a:schemeClr val="accent1"/>
-          </a:effectRef>
-          <a:fontRef idx="minor">
-            <a:schemeClr val="lt1"/>
-          </a:fontRef>
-        </p:style>
-        <p:txBody>
-          <a:bodyPr rtlCol="0" anchor="ctr"/>
-          <a:lstStyle/>
-          <a:p>
-            <a:pPr algn="ctr"/>
-          </a:p>
-        </p:txBody>
-      </p:sp>
-      <p:sp>
-        <p:nvSpPr>
-          <p:cNvPr id="6" name="TextBox 5"/>
-          <p:cNvSpPr txBox="1"/>
-          <p:nvPr/>
-        </p:nvSpPr>
-        <p:spPr>
-          <a:xfrm>
-            <a:off x="612648" y="1335024"/>
-            <a:ext cx="3154679" cy="384048"/>
-          </a:xfrm>
-          <a:prstGeom prst="rect">
-            <a:avLst/>
-          </a:prstGeom>
-          <a:noFill/>
-        </p:spPr>
-        <p:txBody>
-          <a:bodyPr wrap="square" anchor="t">
-            <a:spAutoFit/>
-          </a:bodyPr>
-          <a:lstStyle/>
-          <a:p>
-            <a:pPr algn="l">
-              <a:defRPr sz="1700" b="1">
-                <a:solidFill>
-                  <a:srgbClr val="102A43"/>
-                </a:solidFill>
-                <a:latin typeface="Aptos"/>
-              </a:defRPr>
-            </a:pPr>
-            <a:r>
-              <a:t>1 • Mix prompt/internal states</a:t>
-            </a:r>
-          </a:p>
-        </p:txBody>
-      </p:sp>
-      <p:sp>
-        <p:nvSpPr>
-          <p:cNvPr id="7" name="TextBox 6"/>
-          <p:cNvSpPr txBox="1"/>
-          <p:nvPr/>
-        </p:nvSpPr>
-        <p:spPr>
-          <a:xfrm>
-            <a:off x="612648" y="1783080"/>
-            <a:ext cx="3127248" cy="1097280"/>
-          </a:xfrm>
-          <a:prstGeom prst="rect">
-            <a:avLst/>
-          </a:prstGeom>
-          <a:noFill/>
-        </p:spPr>
-        <p:txBody>
-          <a:bodyPr wrap="square" anchor="t">
-            <a:spAutoFit/>
-          </a:bodyPr>
-          <a:lstStyle/>
-          <a:p>
-            <a:pPr algn="l">
-              <a:defRPr sz="1400" b="0">
+          <p:cNvPr id="4" name="TextBox 3"/>
+          <p:cNvSpPr txBox="1"/>
+          <p:nvPr/>
+        </p:nvSpPr>
+        <p:spPr>
+          <a:xfrm>
+            <a:off x="914400" y="1280160"/>
+            <a:ext cx="10424160" cy="4937760"/>
+          </a:xfrm>
+          <a:prstGeom prst="rect">
+            <a:avLst/>
+          </a:prstGeom>
+          <a:noFill/>
+        </p:spPr>
+        <p:txBody>
+          <a:bodyPr wrap="square">
+            <a:spAutoFit/>
+          </a:bodyPr>
+          <a:lstStyle/>
+          <a:p>
+            <a:pPr>
+              <a:spcAft>
+                <a:spcPts val="1000"/>
+              </a:spcAft>
+              <a:defRPr sz="2100">
                 <a:solidFill>
                   <a:srgbClr val="0F172A"/>
                 </a:solidFill>
@@ -9047,159 +9351,15 @@
               </a:defRPr>
             </a:pPr>
             <a:r>
-              <a:t>Blank-canvas final-state and output-logit methods were tested. Result: 0/42 strict numerical hybrids.</a:t>
-            </a:r>
-          </a:p>
-        </p:txBody>
-      </p:sp>
-      <p:sp>
-        <p:nvSpPr>
-          <p:cNvPr id="8" name="Rounded Rectangle 7"/>
-          <p:cNvSpPr/>
-          <p:nvPr/>
-        </p:nvSpPr>
-        <p:spPr>
-          <a:xfrm>
-            <a:off x="4352544" y="1188720"/>
-            <a:ext cx="3474720" cy="1828800"/>
-          </a:xfrm>
-          <a:prstGeom prst="roundRect">
-            <a:avLst/>
-          </a:prstGeom>
-          <a:solidFill>
-            <a:srgbClr val="FFFFFF"/>
-          </a:solidFill>
-          <a:ln>
-            <a:solidFill>
-              <a:srgbClr val="D8E1EE"/>
-            </a:solidFill>
-          </a:ln>
-        </p:spPr>
-        <p:style>
-          <a:lnRef idx="1">
-            <a:schemeClr val="accent1"/>
-          </a:lnRef>
-          <a:fillRef idx="3">
-            <a:schemeClr val="accent1"/>
-          </a:fillRef>
-          <a:effectRef idx="2">
-            <a:schemeClr val="accent1"/>
-          </a:effectRef>
-          <a:fontRef idx="minor">
-            <a:schemeClr val="lt1"/>
-          </a:fontRef>
-        </p:style>
-        <p:txBody>
-          <a:bodyPr rtlCol="0" anchor="ctr"/>
-          <a:lstStyle/>
-          <a:p>
-            <a:pPr algn="ctr"/>
-          </a:p>
-        </p:txBody>
-      </p:sp>
-      <p:sp>
-        <p:nvSpPr>
-          <p:cNvPr id="9" name="Rectangle 8"/>
-          <p:cNvSpPr/>
-          <p:nvPr/>
-        </p:nvSpPr>
-        <p:spPr>
-          <a:xfrm>
-            <a:off x="4352544" y="1188720"/>
-            <a:ext cx="91440" cy="1828800"/>
-          </a:xfrm>
-          <a:prstGeom prst="rect">
-            <a:avLst/>
-          </a:prstGeom>
-          <a:solidFill>
-            <a:srgbClr val="B45309"/>
-          </a:solidFill>
-          <a:ln>
-            <a:noFill/>
-          </a:ln>
-        </p:spPr>
-        <p:style>
-          <a:lnRef idx="1">
-            <a:schemeClr val="accent1"/>
-          </a:lnRef>
-          <a:fillRef idx="3">
-            <a:schemeClr val="accent1"/>
-          </a:fillRef>
-          <a:effectRef idx="2">
-            <a:schemeClr val="accent1"/>
-          </a:effectRef>
-          <a:fontRef idx="minor">
-            <a:schemeClr val="lt1"/>
-          </a:fontRef>
-        </p:style>
-        <p:txBody>
-          <a:bodyPr rtlCol="0" anchor="ctr"/>
-          <a:lstStyle/>
-          <a:p>
-            <a:pPr algn="ctr"/>
-          </a:p>
-        </p:txBody>
-      </p:sp>
-      <p:sp>
-        <p:nvSpPr>
-          <p:cNvPr id="10" name="TextBox 9"/>
-          <p:cNvSpPr txBox="1"/>
-          <p:nvPr/>
-        </p:nvSpPr>
-        <p:spPr>
-          <a:xfrm>
-            <a:off x="4553712" y="1335024"/>
-            <a:ext cx="3154679" cy="384048"/>
-          </a:xfrm>
-          <a:prstGeom prst="rect">
-            <a:avLst/>
-          </a:prstGeom>
-          <a:noFill/>
-        </p:spPr>
-        <p:txBody>
-          <a:bodyPr wrap="square" anchor="t">
-            <a:spAutoFit/>
-          </a:bodyPr>
-          <a:lstStyle/>
-          <a:p>
-            <a:pPr algn="l">
-              <a:defRPr sz="1700" b="1">
-                <a:solidFill>
-                  <a:srgbClr val="102A43"/>
-                </a:solidFill>
-                <a:latin typeface="Aptos"/>
-              </a:defRPr>
-            </a:pPr>
-            <a:r>
-              <a:t>2 • Darwin ideas/programs</a:t>
-            </a:r>
-          </a:p>
-        </p:txBody>
-      </p:sp>
-      <p:sp>
-        <p:nvSpPr>
-          <p:cNvPr id="11" name="TextBox 10"/>
-          <p:cNvSpPr txBox="1"/>
-          <p:nvPr/>
-        </p:nvSpPr>
-        <p:spPr>
-          <a:xfrm>
-            <a:off x="4553712" y="1783080"/>
-            <a:ext cx="3127248" cy="1097280"/>
-          </a:xfrm>
-          <a:prstGeom prst="rect">
-            <a:avLst/>
-          </a:prstGeom>
-          <a:noFill/>
-        </p:spPr>
-        <p:txBody>
-          <a:bodyPr wrap="square" anchor="t">
-            <a:spAutoFit/>
-          </a:bodyPr>
-          <a:lstStyle/>
-          <a:p>
-            <a:pPr algn="l">
-              <a:defRPr sz="1400" b="0">
+              <a:t>Reproducible full-model execution with seeds, hashes, revisions, timings, and preserved raw outputs.</a:t>
+            </a:r>
+          </a:p>
+          <a:p>
+            <a:pPr>
+              <a:spcAft>
+                <a:spcPts val="1000"/>
+              </a:spcAft>
+              <a:defRPr sz="2100">
                 <a:solidFill>
                   <a:srgbClr val="0F172A"/>
                 </a:solidFill>
@@ -9207,159 +9367,15 @@
               </a:defRPr>
             </a:pPr>
             <a:r>
-              <a:t>Darwin-derived ideas were used; code-state controls were invalid. No Darwin program fitness gain was established.</a:t>
-            </a:r>
-          </a:p>
-        </p:txBody>
-      </p:sp>
-      <p:sp>
-        <p:nvSpPr>
-          <p:cNvPr id="12" name="Rounded Rectangle 11"/>
-          <p:cNvSpPr/>
-          <p:nvPr/>
-        </p:nvSpPr>
-        <p:spPr>
-          <a:xfrm>
-            <a:off x="8293608" y="1188720"/>
-            <a:ext cx="3474720" cy="1828800"/>
-          </a:xfrm>
-          <a:prstGeom prst="roundRect">
-            <a:avLst/>
-          </a:prstGeom>
-          <a:solidFill>
-            <a:srgbClr val="FFFFFF"/>
-          </a:solidFill>
-          <a:ln>
-            <a:solidFill>
-              <a:srgbClr val="D8E1EE"/>
-            </a:solidFill>
-          </a:ln>
-        </p:spPr>
-        <p:style>
-          <a:lnRef idx="1">
-            <a:schemeClr val="accent1"/>
-          </a:lnRef>
-          <a:fillRef idx="3">
-            <a:schemeClr val="accent1"/>
-          </a:fillRef>
-          <a:effectRef idx="2">
-            <a:schemeClr val="accent1"/>
-          </a:effectRef>
-          <a:fontRef idx="minor">
-            <a:schemeClr val="lt1"/>
-          </a:fontRef>
-        </p:style>
-        <p:txBody>
-          <a:bodyPr rtlCol="0" anchor="ctr"/>
-          <a:lstStyle/>
-          <a:p>
-            <a:pPr algn="ctr"/>
-          </a:p>
-        </p:txBody>
-      </p:sp>
-      <p:sp>
-        <p:nvSpPr>
-          <p:cNvPr id="13" name="Rectangle 12"/>
-          <p:cNvSpPr/>
-          <p:nvPr/>
-        </p:nvSpPr>
-        <p:spPr>
-          <a:xfrm>
-            <a:off x="8293608" y="1188720"/>
-            <a:ext cx="91440" cy="1828800"/>
-          </a:xfrm>
-          <a:prstGeom prst="rect">
-            <a:avLst/>
-          </a:prstGeom>
-          <a:solidFill>
-            <a:srgbClr val="B91C1C"/>
-          </a:solidFill>
-          <a:ln>
-            <a:noFill/>
-          </a:ln>
-        </p:spPr>
-        <p:style>
-          <a:lnRef idx="1">
-            <a:schemeClr val="accent1"/>
-          </a:lnRef>
-          <a:fillRef idx="3">
-            <a:schemeClr val="accent1"/>
-          </a:fillRef>
-          <a:effectRef idx="2">
-            <a:schemeClr val="accent1"/>
-          </a:effectRef>
-          <a:fontRef idx="minor">
-            <a:schemeClr val="lt1"/>
-          </a:fontRef>
-        </p:style>
-        <p:txBody>
-          <a:bodyPr rtlCol="0" anchor="ctr"/>
-          <a:lstStyle/>
-          <a:p>
-            <a:pPr algn="ctr"/>
-          </a:p>
-        </p:txBody>
-      </p:sp>
-      <p:sp>
-        <p:nvSpPr>
-          <p:cNvPr id="14" name="TextBox 13"/>
-          <p:cNvSpPr txBox="1"/>
-          <p:nvPr/>
-        </p:nvSpPr>
-        <p:spPr>
-          <a:xfrm>
-            <a:off x="8494776" y="1335024"/>
-            <a:ext cx="3154679" cy="384048"/>
-          </a:xfrm>
-          <a:prstGeom prst="rect">
-            <a:avLst/>
-          </a:prstGeom>
-          <a:noFill/>
-        </p:spPr>
-        <p:txBody>
-          <a:bodyPr wrap="square" anchor="t">
-            <a:spAutoFit/>
-          </a:bodyPr>
-          <a:lstStyle/>
-          <a:p>
-            <a:pPr algn="l">
-              <a:defRPr sz="1700" b="1">
-                <a:solidFill>
-                  <a:srgbClr val="102A43"/>
-                </a:solidFill>
-                <a:latin typeface="Aptos"/>
-              </a:defRPr>
-            </a:pPr>
-            <a:r>
-              <a:t>3 • Partial denoise → larger AR</a:t>
-            </a:r>
-          </a:p>
-        </p:txBody>
-      </p:sp>
-      <p:sp>
-        <p:nvSpPr>
-          <p:cNvPr id="15" name="TextBox 14"/>
-          <p:cNvSpPr txBox="1"/>
-          <p:nvPr/>
-        </p:nvSpPr>
-        <p:spPr>
-          <a:xfrm>
-            <a:off x="8494776" y="1783080"/>
-            <a:ext cx="3127248" cy="1097280"/>
-          </a:xfrm>
-          <a:prstGeom prst="rect">
-            <a:avLst/>
-          </a:prstGeom>
-          <a:noFill/>
-        </p:spPr>
-        <p:txBody>
-          <a:bodyPr wrap="square" anchor="t">
-            <a:spAutoFit/>
-          </a:bodyPr>
-          <a:lstStyle/>
-          <a:p>
-            <a:pPr algn="l">
-              <a:defRPr sz="1400" b="0">
+              <a:t>Endpoint decoding when prompts named the required implementation details.</a:t>
+            </a:r>
+          </a:p>
+          <a:p>
+            <a:pPr>
+              <a:spcAft>
+                <a:spcPts val="1000"/>
+              </a:spcAft>
+              <a:defRPr sz="2100">
                 <a:solidFill>
                   <a:srgbClr val="0F172A"/>
                 </a:solidFill>
@@ -9367,159 +9383,15 @@
               </a:defRPr>
             </a:pPr>
             <a:r>
-              <a:t>Earlier pilot: 0/15 useful scaffolds; scaffold-only handoff recovered neither parent in 0/4. It added no useful information.</a:t>
-            </a:r>
-          </a:p>
-        </p:txBody>
-      </p:sp>
-      <p:sp>
-        <p:nvSpPr>
-          <p:cNvPr id="16" name="Rounded Rectangle 15"/>
-          <p:cNvSpPr/>
-          <p:nvPr/>
-        </p:nvSpPr>
-        <p:spPr>
-          <a:xfrm>
-            <a:off x="1143000" y="3337560"/>
-            <a:ext cx="4800600" cy="1691640"/>
-          </a:xfrm>
-          <a:prstGeom prst="roundRect">
-            <a:avLst/>
-          </a:prstGeom>
-          <a:solidFill>
-            <a:srgbClr val="FFFFFF"/>
-          </a:solidFill>
-          <a:ln>
-            <a:solidFill>
-              <a:srgbClr val="D8E1EE"/>
-            </a:solidFill>
-          </a:ln>
-        </p:spPr>
-        <p:style>
-          <a:lnRef idx="1">
-            <a:schemeClr val="accent1"/>
-          </a:lnRef>
-          <a:fillRef idx="3">
-            <a:schemeClr val="accent1"/>
-          </a:fillRef>
-          <a:effectRef idx="2">
-            <a:schemeClr val="accent1"/>
-          </a:effectRef>
-          <a:fontRef idx="minor">
-            <a:schemeClr val="lt1"/>
-          </a:fontRef>
-        </p:style>
-        <p:txBody>
-          <a:bodyPr rtlCol="0" anchor="ctr"/>
-          <a:lstStyle/>
-          <a:p>
-            <a:pPr algn="ctr"/>
-          </a:p>
-        </p:txBody>
-      </p:sp>
-      <p:sp>
-        <p:nvSpPr>
-          <p:cNvPr id="17" name="Rectangle 16"/>
-          <p:cNvSpPr/>
-          <p:nvPr/>
-        </p:nvSpPr>
-        <p:spPr>
-          <a:xfrm>
-            <a:off x="1143000" y="3337560"/>
-            <a:ext cx="91440" cy="1691640"/>
-          </a:xfrm>
-          <a:prstGeom prst="rect">
-            <a:avLst/>
-          </a:prstGeom>
-          <a:solidFill>
-            <a:srgbClr val="B91C1C"/>
-          </a:solidFill>
-          <a:ln>
-            <a:noFill/>
-          </a:ln>
-        </p:spPr>
-        <p:style>
-          <a:lnRef idx="1">
-            <a:schemeClr val="accent1"/>
-          </a:lnRef>
-          <a:fillRef idx="3">
-            <a:schemeClr val="accent1"/>
-          </a:fillRef>
-          <a:effectRef idx="2">
-            <a:schemeClr val="accent1"/>
-          </a:effectRef>
-          <a:fontRef idx="minor">
-            <a:schemeClr val="lt1"/>
-          </a:fontRef>
-        </p:style>
-        <p:txBody>
-          <a:bodyPr rtlCol="0" anchor="ctr"/>
-          <a:lstStyle/>
-          <a:p>
-            <a:pPr algn="ctr"/>
-          </a:p>
-        </p:txBody>
-      </p:sp>
-      <p:sp>
-        <p:nvSpPr>
-          <p:cNvPr id="18" name="TextBox 17"/>
-          <p:cNvSpPr txBox="1"/>
-          <p:nvPr/>
-        </p:nvSpPr>
-        <p:spPr>
-          <a:xfrm>
-            <a:off x="1344168" y="3483864"/>
-            <a:ext cx="4480560" cy="384048"/>
-          </a:xfrm>
-          <a:prstGeom prst="rect">
-            <a:avLst/>
-          </a:prstGeom>
-          <a:noFill/>
-        </p:spPr>
-        <p:txBody>
-          <a:bodyPr wrap="square" anchor="t">
-            <a:spAutoFit/>
-          </a:bodyPr>
-          <a:lstStyle/>
-          <a:p>
-            <a:pPr algn="l">
-              <a:defRPr sz="1700" b="1">
-                <a:solidFill>
-                  <a:srgbClr val="102A43"/>
-                </a:solidFill>
-                <a:latin typeface="Aptos"/>
-              </a:defRPr>
-            </a:pPr>
-            <a:r>
-              <a:t>4 • Bayesian optimization</a:t>
-            </a:r>
-          </a:p>
-        </p:txBody>
-      </p:sp>
-      <p:sp>
-        <p:nvSpPr>
-          <p:cNvPr id="19" name="TextBox 18"/>
-          <p:cNvSpPr txBox="1"/>
-          <p:nvPr/>
-        </p:nvSpPr>
-        <p:spPr>
-          <a:xfrm>
-            <a:off x="1344168" y="3931920"/>
-            <a:ext cx="4453128" cy="960120"/>
-          </a:xfrm>
-          <a:prstGeom prst="rect">
-            <a:avLst/>
-          </a:prstGeom>
-          <a:noFill/>
-        </p:spPr>
-        <p:txBody>
-          <a:bodyPr wrap="square" anchor="t">
-            <a:spAutoFit/>
-          </a:bodyPr>
-          <a:lstStyle/>
-          <a:p>
-            <a:pPr algn="l">
-              <a:defRPr sz="1400" b="0">
+              <a:t>A causal diagnostic: poor composition was not explained by simple vector cancellation.</a:t>
+            </a:r>
+          </a:p>
+          <a:p>
+            <a:pPr>
+              <a:spcAft>
+                <a:spcPts val="1000"/>
+              </a:spcAft>
+              <a:defRPr sz="2100">
                 <a:solidFill>
                   <a:srgbClr val="0F172A"/>
                 </a:solidFill>
@@ -9527,159 +9399,15 @@
               </a:defRPr>
             </a:pPr>
             <a:r>
-              <a:t>Not justified: the tested coordinate crosses a broad unrelated region rather than a smooth useful bridge.</a:t>
-            </a:r>
-          </a:p>
-        </p:txBody>
-      </p:sp>
-      <p:sp>
-        <p:nvSpPr>
-          <p:cNvPr id="20" name="Rounded Rectangle 19"/>
-          <p:cNvSpPr/>
-          <p:nvPr/>
-        </p:nvSpPr>
-        <p:spPr>
-          <a:xfrm>
-            <a:off x="6245352" y="3337560"/>
-            <a:ext cx="4800600" cy="1691640"/>
-          </a:xfrm>
-          <a:prstGeom prst="roundRect">
-            <a:avLst/>
-          </a:prstGeom>
-          <a:solidFill>
-            <a:srgbClr val="FFFFFF"/>
-          </a:solidFill>
-          <a:ln>
-            <a:solidFill>
-              <a:srgbClr val="D8E1EE"/>
-            </a:solidFill>
-          </a:ln>
-        </p:spPr>
-        <p:style>
-          <a:lnRef idx="1">
-            <a:schemeClr val="accent1"/>
-          </a:lnRef>
-          <a:fillRef idx="3">
-            <a:schemeClr val="accent1"/>
-          </a:fillRef>
-          <a:effectRef idx="2">
-            <a:schemeClr val="accent1"/>
-          </a:effectRef>
-          <a:fontRef idx="minor">
-            <a:schemeClr val="lt1"/>
-          </a:fontRef>
-        </p:style>
-        <p:txBody>
-          <a:bodyPr rtlCol="0" anchor="ctr"/>
-          <a:lstStyle/>
-          <a:p>
-            <a:pPr algn="ctr"/>
-          </a:p>
-        </p:txBody>
-      </p:sp>
-      <p:sp>
-        <p:nvSpPr>
-          <p:cNvPr id="21" name="Rectangle 20"/>
-          <p:cNvSpPr/>
-          <p:nvPr/>
-        </p:nvSpPr>
-        <p:spPr>
-          <a:xfrm>
-            <a:off x="6245352" y="3337560"/>
-            <a:ext cx="91440" cy="1691640"/>
-          </a:xfrm>
-          <a:prstGeom prst="rect">
-            <a:avLst/>
-          </a:prstGeom>
-          <a:solidFill>
-            <a:srgbClr val="7C3AED"/>
-          </a:solidFill>
-          <a:ln>
-            <a:noFill/>
-          </a:ln>
-        </p:spPr>
-        <p:style>
-          <a:lnRef idx="1">
-            <a:schemeClr val="accent1"/>
-          </a:lnRef>
-          <a:fillRef idx="3">
-            <a:schemeClr val="accent1"/>
-          </a:fillRef>
-          <a:effectRef idx="2">
-            <a:schemeClr val="accent1"/>
-          </a:effectRef>
-          <a:fontRef idx="minor">
-            <a:schemeClr val="lt1"/>
-          </a:fontRef>
-        </p:style>
-        <p:txBody>
-          <a:bodyPr rtlCol="0" anchor="ctr"/>
-          <a:lstStyle/>
-          <a:p>
-            <a:pPr algn="ctr"/>
-          </a:p>
-        </p:txBody>
-      </p:sp>
-      <p:sp>
-        <p:nvSpPr>
-          <p:cNvPr id="22" name="TextBox 21"/>
-          <p:cNvSpPr txBox="1"/>
-          <p:nvPr/>
-        </p:nvSpPr>
-        <p:spPr>
-          <a:xfrm>
-            <a:off x="6446520" y="3483864"/>
-            <a:ext cx="4480560" cy="384048"/>
-          </a:xfrm>
-          <a:prstGeom prst="rect">
-            <a:avLst/>
-          </a:prstGeom>
-          <a:noFill/>
-        </p:spPr>
-        <p:txBody>
-          <a:bodyPr wrap="square" anchor="t">
-            <a:spAutoFit/>
-          </a:bodyPr>
-          <a:lstStyle/>
-          <a:p>
-            <a:pPr algn="l">
-              <a:defRPr sz="1700" b="1">
-                <a:solidFill>
-                  <a:srgbClr val="102A43"/>
-                </a:solidFill>
-                <a:latin typeface="Aptos"/>
-              </a:defRPr>
-            </a:pPr>
-            <a:r>
-              <a:t>5 • Darwin search-stage integration</a:t>
-            </a:r>
-          </a:p>
-        </p:txBody>
-      </p:sp>
-      <p:sp>
-        <p:nvSpPr>
-          <p:cNvPr id="23" name="TextBox 22"/>
-          <p:cNvSpPr txBox="1"/>
-          <p:nvPr/>
-        </p:nvSpPr>
-        <p:spPr>
-          <a:xfrm>
-            <a:off x="6446520" y="3931920"/>
-            <a:ext cx="4453128" cy="960120"/>
-          </a:xfrm>
-          <a:prstGeom prst="rect">
-            <a:avLst/>
-          </a:prstGeom>
-          <a:noFill/>
-        </p:spPr>
-        <p:txBody>
-          <a:bodyPr wrap="square" anchor="t">
-            <a:spAutoFit/>
-          </a:bodyPr>
-          <a:lstStyle/>
-          <a:p>
-            <a:pPr algn="l">
-              <a:defRPr sz="1400" b="0">
+              <a:t>A likely bottleneck: useful endpoint alternatives survived below top-1 but hard projection broke sequence-level meaning.</a:t>
+            </a:r>
+          </a:p>
+          <a:p>
+            <a:pPr>
+              <a:spcAft>
+                <a:spcPts val="1000"/>
+              </a:spcAft>
+              <a:defRPr sz="2100">
                 <a:solidFill>
                   <a:srgbClr val="0F172A"/>
                 </a:solidFill>
@@ -9687,50 +9415,46 @@
               </a:defRPr>
             </a:pPr>
             <a:r>
-              <a:t>Not justified for the failed numerical mixer. Direct text-based idea synthesis remains viable; program-level Darwin evaluation is still untested.</a:t>
-            </a:r>
-          </a:p>
-        </p:txBody>
-      </p:sp>
-      <p:sp>
-        <p:nvSpPr>
-          <p:cNvPr id="24" name="TextBox 23"/>
-          <p:cNvSpPr txBox="1"/>
-          <p:nvPr/>
-        </p:nvSpPr>
-        <p:spPr>
-          <a:xfrm>
-            <a:off x="594360" y="5440680"/>
-            <a:ext cx="10972800" cy="685800"/>
-          </a:xfrm>
-          <a:prstGeom prst="rect">
-            <a:avLst/>
-          </a:prstGeom>
-          <a:noFill/>
-        </p:spPr>
-        <p:txBody>
-          <a:bodyPr wrap="square" anchor="t">
-            <a:spAutoFit/>
-          </a:bodyPr>
-          <a:lstStyle/>
-          <a:p>
-            <a:pPr algn="ctr">
-              <a:defRPr sz="1600" b="1">
-                <a:solidFill>
-                  <a:srgbClr val="102A43"/>
-                </a:solidFill>
-                <a:latin typeface="Aptos"/>
-              </a:defRPr>
-            </a:pPr>
-            <a:r>
-              <a:t>Attribution boundary: internal-layer injection, KV-cache mixing, learned sequence-aware mixing, and preregistered confirmation are our later future-work ideas—not Sergiy’s explicit asks.</a:t>
-            </a:r>
-          </a:p>
-        </p:txBody>
-      </p:sp>
-      <p:sp>
-        <p:nvSpPr>
-          <p:cNvPr id="25" name="TextBox 24"/>
+              <a:t>Direct diffusion prompting composed both parents 17/18 strict times across sorting, matrix, graph, and image pairs.</a:t>
+            </a:r>
+          </a:p>
+          <a:p>
+            <a:pPr>
+              <a:spcAft>
+                <a:spcPts val="1000"/>
+              </a:spcAft>
+              <a:defRPr sz="2100">
+                <a:solidFill>
+                  <a:srgbClr val="0F172A"/>
+                </a:solidFill>
+                <a:latin typeface="Aptos"/>
+              </a:defRPr>
+            </a:pPr>
+            <a:r>
+              <a:t>Full-context blank-canvas prompting independently achieved 8/9, tying rather than improving the concise prompt.</a:t>
+            </a:r>
+          </a:p>
+          <a:p>
+            <a:pPr>
+              <a:spcAft>
+                <a:spcPts val="1000"/>
+              </a:spcAft>
+              <a:defRPr sz="2100">
+                <a:solidFill>
+                  <a:srgbClr val="0F172A"/>
+                </a:solidFill>
+                <a:latin typeface="Aptos"/>
+              </a:defRPr>
+            </a:pPr>
+            <a:r>
+              <a:t>Endpoint gates prevented overinterpreting the blocked histogram and regex pairs.</a:t>
+            </a:r>
+          </a:p>
+        </p:txBody>
+      </p:sp>
+      <p:sp>
+        <p:nvSpPr>
+          <p:cNvPr id="5" name="TextBox 4"/>
           <p:cNvSpPr txBox="1"/>
           <p:nvPr/>
         </p:nvSpPr>
@@ -9759,7 +9483,7 @@
               </a:defRPr>
             </a:pPr>
             <a:r>
-              <a:t>Pilot evidence • September 18, 2026 • experiments/001–012 | earlier pilot: partial-scaffolds and scaffold-handoff assessments | answers-to-sergiy.md</a:t>
+              <a:t>Pilot evidence • September 18, 2026 • experiments/003–012/results/results.json</a:t>
             </a:r>
           </a:p>
         </p:txBody>
@@ -10385,7 +10109,7 @@
               </a:defRPr>
             </a:pPr>
             <a:r>
-              <a:t>Pilot evidence • September 18, 2026 • research design summarized from experiments/001–012/spec.json</a:t>
+              <a:t>Pilot evidence • September 18, 2026 • research design summarized from experiments/001–013/spec.json</a:t>
             </a:r>
           </a:p>
         </p:txBody>
@@ -10447,7 +10171,7 @@
               </a:defRPr>
             </a:pPr>
             <a:r>
-              <a:t>What was not completed—and why</a:t>
+              <a:t>Sergiy’s explicit proposal: status of each item</a:t>
             </a:r>
           </a:p>
         </p:txBody>
@@ -10497,50 +10221,14 @@
       </p:sp>
       <p:sp>
         <p:nvSpPr>
-          <p:cNvPr id="4" name="TextBox 3"/>
-          <p:cNvSpPr txBox="1"/>
-          <p:nvPr/>
-        </p:nvSpPr>
-        <p:spPr>
-          <a:xfrm>
-            <a:off x="2148840" y="841248"/>
-            <a:ext cx="9326880" cy="320040"/>
-          </a:xfrm>
-          <a:prstGeom prst="rect">
-            <a:avLst/>
-          </a:prstGeom>
-          <a:noFill/>
-        </p:spPr>
-        <p:txBody>
-          <a:bodyPr wrap="square" anchor="t">
-            <a:spAutoFit/>
-          </a:bodyPr>
-          <a:lstStyle/>
-          <a:p>
-            <a:pPr algn="l">
-              <a:defRPr sz="1200" b="0">
-                <a:solidFill>
-                  <a:srgbClr val="64748B"/>
-                </a:solidFill>
-                <a:latin typeface="Aptos"/>
-              </a:defRPr>
-            </a:pPr>
-            <a:r>
-              <a:t>Implementation aspirations were gated by the research result</a:t>
-            </a:r>
-          </a:p>
-        </p:txBody>
-      </p:sp>
-      <p:sp>
-        <p:nvSpPr>
-          <p:cNvPr id="5" name="Rounded Rectangle 4"/>
+          <p:cNvPr id="4" name="Rounded Rectangle 3"/>
           <p:cNvSpPr/>
           <p:nvPr/>
         </p:nvSpPr>
         <p:spPr>
           <a:xfrm>
-            <a:off x="594360" y="1325880"/>
-            <a:ext cx="3474720" cy="3977639"/>
+            <a:off x="411480" y="1188720"/>
+            <a:ext cx="3474720" cy="1828800"/>
           </a:xfrm>
           <a:prstGeom prst="roundRect">
             <a:avLst/>
@@ -10578,20 +10266,20 @@
       </p:sp>
       <p:sp>
         <p:nvSpPr>
-          <p:cNvPr id="6" name="Rectangle 5"/>
+          <p:cNvPr id="5" name="Rectangle 4"/>
           <p:cNvSpPr/>
           <p:nvPr/>
         </p:nvSpPr>
         <p:spPr>
           <a:xfrm>
-            <a:off x="594360" y="1325880"/>
-            <a:ext cx="91440" cy="3977639"/>
+            <a:off x="411480" y="1188720"/>
+            <a:ext cx="91440" cy="1828800"/>
           </a:xfrm>
           <a:prstGeom prst="rect">
             <a:avLst/>
           </a:prstGeom>
           <a:solidFill>
-            <a:srgbClr val="7C3AED"/>
+            <a:srgbClr val="B91C1C"/>
           </a:solidFill>
           <a:ln>
             <a:noFill/>
@@ -10621,13 +10309,13 @@
       </p:sp>
       <p:sp>
         <p:nvSpPr>
-          <p:cNvPr id="7" name="TextBox 6"/>
-          <p:cNvSpPr txBox="1"/>
-          <p:nvPr/>
-        </p:nvSpPr>
-        <p:spPr>
-          <a:xfrm>
-            <a:off x="795528" y="1472184"/>
+          <p:cNvPr id="6" name="TextBox 5"/>
+          <p:cNvSpPr txBox="1"/>
+          <p:nvPr/>
+        </p:nvSpPr>
+        <p:spPr>
+          <a:xfrm>
+            <a:off x="612648" y="1335024"/>
             <a:ext cx="3154679" cy="384048"/>
           </a:xfrm>
           <a:prstGeom prst="rect">
@@ -10650,21 +10338,21 @@
               </a:defRPr>
             </a:pPr>
             <a:r>
-              <a:t>No production Darwin stage</a:t>
-            </a:r>
-          </a:p>
-        </p:txBody>
-      </p:sp>
-      <p:sp>
-        <p:nvSpPr>
-          <p:cNvPr id="8" name="TextBox 7"/>
-          <p:cNvSpPr txBox="1"/>
-          <p:nvPr/>
-        </p:nvSpPr>
-        <p:spPr>
-          <a:xfrm>
-            <a:off x="795528" y="1920240"/>
-            <a:ext cx="3127248" cy="3246120"/>
+              <a:t>1 • Mix prompt/internal states</a:t>
+            </a:r>
+          </a:p>
+        </p:txBody>
+      </p:sp>
+      <p:sp>
+        <p:nvSpPr>
+          <p:cNvPr id="7" name="TextBox 6"/>
+          <p:cNvSpPr txBox="1"/>
+          <p:nvPr/>
+        </p:nvSpPr>
+        <p:spPr>
+          <a:xfrm>
+            <a:off x="612648" y="1783080"/>
+            <a:ext cx="3127248" cy="1097280"/>
           </a:xfrm>
           <a:prstGeom prst="rect">
             <a:avLst/>
@@ -10686,21 +10374,21 @@
               </a:defRPr>
             </a:pPr>
             <a:r>
-              <a:t>The tested numerical synthesis mechanism showed no benefit. Building it into the production sampling pipeline was therefore not scientifically justified.</a:t>
-            </a:r>
-          </a:p>
-        </p:txBody>
-      </p:sp>
-      <p:sp>
-        <p:nvSpPr>
-          <p:cNvPr id="9" name="Rounded Rectangle 8"/>
+              <a:t>Blank-canvas final-state and output-logit methods were tested. Result: 0/42 strict numerical hybrids.</a:t>
+            </a:r>
+          </a:p>
+        </p:txBody>
+      </p:sp>
+      <p:sp>
+        <p:nvSpPr>
+          <p:cNvPr id="8" name="Rounded Rectangle 7"/>
           <p:cNvSpPr/>
           <p:nvPr/>
         </p:nvSpPr>
         <p:spPr>
           <a:xfrm>
-            <a:off x="4361688" y="1325880"/>
-            <a:ext cx="3474720" cy="3977639"/>
+            <a:off x="4352544" y="1188720"/>
+            <a:ext cx="3474720" cy="1828800"/>
           </a:xfrm>
           <a:prstGeom prst="roundRect">
             <a:avLst/>
@@ -10738,20 +10426,20 @@
       </p:sp>
       <p:sp>
         <p:nvSpPr>
-          <p:cNvPr id="10" name="Rectangle 9"/>
+          <p:cNvPr id="9" name="Rectangle 8"/>
           <p:cNvSpPr/>
           <p:nvPr/>
         </p:nvSpPr>
         <p:spPr>
           <a:xfrm>
-            <a:off x="4361688" y="1325880"/>
-            <a:ext cx="91440" cy="3977639"/>
+            <a:off x="4352544" y="1188720"/>
+            <a:ext cx="91440" cy="1828800"/>
           </a:xfrm>
           <a:prstGeom prst="rect">
             <a:avLst/>
           </a:prstGeom>
           <a:solidFill>
-            <a:srgbClr val="B91C1C"/>
+            <a:srgbClr val="B45309"/>
           </a:solidFill>
           <a:ln>
             <a:noFill/>
@@ -10781,13 +10469,13 @@
       </p:sp>
       <p:sp>
         <p:nvSpPr>
-          <p:cNvPr id="11" name="TextBox 10"/>
-          <p:cNvSpPr txBox="1"/>
-          <p:nvPr/>
-        </p:nvSpPr>
-        <p:spPr>
-          <a:xfrm>
-            <a:off x="4562855" y="1472184"/>
+          <p:cNvPr id="10" name="TextBox 9"/>
+          <p:cNvSpPr txBox="1"/>
+          <p:nvPr/>
+        </p:nvSpPr>
+        <p:spPr>
+          <a:xfrm>
+            <a:off x="4553712" y="1335024"/>
             <a:ext cx="3154679" cy="384048"/>
           </a:xfrm>
           <a:prstGeom prst="rect">
@@ -10810,21 +10498,21 @@
               </a:defRPr>
             </a:pPr>
             <a:r>
-              <a:t>No Bayesian optimizer run</a:t>
-            </a:r>
-          </a:p>
-        </p:txBody>
-      </p:sp>
-      <p:sp>
-        <p:nvSpPr>
-          <p:cNvPr id="12" name="TextBox 11"/>
-          <p:cNvSpPr txBox="1"/>
-          <p:nvPr/>
-        </p:nvSpPr>
-        <p:spPr>
-          <a:xfrm>
-            <a:off x="4562855" y="1920240"/>
-            <a:ext cx="3127248" cy="3246120"/>
+              <a:t>2 • Darwin ideas/programs</a:t>
+            </a:r>
+          </a:p>
+        </p:txBody>
+      </p:sp>
+      <p:sp>
+        <p:nvSpPr>
+          <p:cNvPr id="11" name="TextBox 10"/>
+          <p:cNvSpPr txBox="1"/>
+          <p:nvPr/>
+        </p:nvSpPr>
+        <p:spPr>
+          <a:xfrm>
+            <a:off x="4553712" y="1783080"/>
+            <a:ext cx="3127248" cy="1097280"/>
           </a:xfrm>
           <a:prstGeom prst="rect">
             <a:avLst/>
@@ -10846,21 +10534,21 @@
               </a:defRPr>
             </a:pPr>
             <a:r>
-              <a:t>The smooth-coordinate gate failed: the path crossed a broad unrelated region instead of a useful continuous semantic space.</a:t>
-            </a:r>
-          </a:p>
-        </p:txBody>
-      </p:sp>
-      <p:sp>
-        <p:nvSpPr>
-          <p:cNvPr id="13" name="Rounded Rectangle 12"/>
+              <a:t>Darwin-derived ideas were used; code-state controls were invalid. No Darwin program fitness gain was established.</a:t>
+            </a:r>
+          </a:p>
+        </p:txBody>
+      </p:sp>
+      <p:sp>
+        <p:nvSpPr>
+          <p:cNvPr id="12" name="Rounded Rectangle 11"/>
           <p:cNvSpPr/>
           <p:nvPr/>
         </p:nvSpPr>
         <p:spPr>
           <a:xfrm>
-            <a:off x="8129016" y="1325880"/>
-            <a:ext cx="3474720" cy="3977639"/>
+            <a:off x="8293608" y="1188720"/>
+            <a:ext cx="3474720" cy="1828800"/>
           </a:xfrm>
           <a:prstGeom prst="roundRect">
             <a:avLst/>
@@ -10898,20 +10586,20 @@
       </p:sp>
       <p:sp>
         <p:nvSpPr>
-          <p:cNvPr id="14" name="Rectangle 13"/>
+          <p:cNvPr id="13" name="Rectangle 12"/>
           <p:cNvSpPr/>
           <p:nvPr/>
         </p:nvSpPr>
         <p:spPr>
           <a:xfrm>
-            <a:off x="8129016" y="1325880"/>
-            <a:ext cx="91440" cy="3977639"/>
+            <a:off x="8293608" y="1188720"/>
+            <a:ext cx="91440" cy="1828800"/>
           </a:xfrm>
           <a:prstGeom prst="rect">
             <a:avLst/>
           </a:prstGeom>
           <a:solidFill>
-            <a:srgbClr val="B45309"/>
+            <a:srgbClr val="B91C1C"/>
           </a:solidFill>
           <a:ln>
             <a:noFill/>
@@ -10941,13 +10629,13 @@
       </p:sp>
       <p:sp>
         <p:nvSpPr>
-          <p:cNvPr id="15" name="TextBox 14"/>
-          <p:cNvSpPr txBox="1"/>
-          <p:nvPr/>
-        </p:nvSpPr>
-        <p:spPr>
-          <a:xfrm>
-            <a:off x="8330184" y="1472184"/>
+          <p:cNvPr id="14" name="TextBox 13"/>
+          <p:cNvSpPr txBox="1"/>
+          <p:nvPr/>
+        </p:nvSpPr>
+        <p:spPr>
+          <a:xfrm>
+            <a:off x="8494776" y="1335024"/>
             <a:ext cx="3154679" cy="384048"/>
           </a:xfrm>
           <a:prstGeom prst="rect">
@@ -10970,21 +10658,21 @@
               </a:defRPr>
             </a:pPr>
             <a:r>
-              <a:t>No program campaign</a:t>
-            </a:r>
-          </a:p>
-        </p:txBody>
-      </p:sp>
-      <p:sp>
-        <p:nvSpPr>
-          <p:cNvPr id="16" name="TextBox 15"/>
-          <p:cNvSpPr txBox="1"/>
-          <p:nvPr/>
-        </p:nvSpPr>
-        <p:spPr>
-          <a:xfrm>
-            <a:off x="8330184" y="1920240"/>
-            <a:ext cx="3127248" cy="3246120"/>
+              <a:t>3 • Partial denoise → larger AR</a:t>
+            </a:r>
+          </a:p>
+        </p:txBody>
+      </p:sp>
+      <p:sp>
+        <p:nvSpPr>
+          <p:cNvPr id="15" name="TextBox 14"/>
+          <p:cNvSpPr txBox="1"/>
+          <p:nvPr/>
+        </p:nvSpPr>
+        <p:spPr>
+          <a:xfrm>
+            <a:off x="8494776" y="1783080"/>
+            <a:ext cx="3127248" cy="1097280"/>
           </a:xfrm>
           <a:prstGeom prst="rect">
             <a:avLst/>
@@ -11006,21 +10694,341 @@
               </a:defRPr>
             </a:pPr>
             <a:r>
-              <a:t>No end-to-end generated-program compilation, test, and benchmark campaign followed because the numerical method produced no useful synthesized idea to advance.</a:t>
-            </a:r>
-          </a:p>
-        </p:txBody>
-      </p:sp>
-      <p:sp>
-        <p:nvSpPr>
-          <p:cNvPr id="17" name="TextBox 16"/>
-          <p:cNvSpPr txBox="1"/>
-          <p:nvPr/>
-        </p:nvSpPr>
-        <p:spPr>
-          <a:xfrm>
-            <a:off x="685800" y="5532120"/>
-            <a:ext cx="10835640" cy="640080"/>
+              <a:t>Earlier pilot: 0/15 useful scaffolds; scaffold-only handoff recovered neither parent in 0/4. It added no useful information.</a:t>
+            </a:r>
+          </a:p>
+        </p:txBody>
+      </p:sp>
+      <p:sp>
+        <p:nvSpPr>
+          <p:cNvPr id="16" name="Rounded Rectangle 15"/>
+          <p:cNvSpPr/>
+          <p:nvPr/>
+        </p:nvSpPr>
+        <p:spPr>
+          <a:xfrm>
+            <a:off x="1143000" y="3337560"/>
+            <a:ext cx="4800600" cy="1691640"/>
+          </a:xfrm>
+          <a:prstGeom prst="roundRect">
+            <a:avLst/>
+          </a:prstGeom>
+          <a:solidFill>
+            <a:srgbClr val="FFFFFF"/>
+          </a:solidFill>
+          <a:ln>
+            <a:solidFill>
+              <a:srgbClr val="D8E1EE"/>
+            </a:solidFill>
+          </a:ln>
+        </p:spPr>
+        <p:style>
+          <a:lnRef idx="1">
+            <a:schemeClr val="accent1"/>
+          </a:lnRef>
+          <a:fillRef idx="3">
+            <a:schemeClr val="accent1"/>
+          </a:fillRef>
+          <a:effectRef idx="2">
+            <a:schemeClr val="accent1"/>
+          </a:effectRef>
+          <a:fontRef idx="minor">
+            <a:schemeClr val="lt1"/>
+          </a:fontRef>
+        </p:style>
+        <p:txBody>
+          <a:bodyPr rtlCol="0" anchor="ctr"/>
+          <a:lstStyle/>
+          <a:p>
+            <a:pPr algn="ctr"/>
+          </a:p>
+        </p:txBody>
+      </p:sp>
+      <p:sp>
+        <p:nvSpPr>
+          <p:cNvPr id="17" name="Rectangle 16"/>
+          <p:cNvSpPr/>
+          <p:nvPr/>
+        </p:nvSpPr>
+        <p:spPr>
+          <a:xfrm>
+            <a:off x="1143000" y="3337560"/>
+            <a:ext cx="91440" cy="1691640"/>
+          </a:xfrm>
+          <a:prstGeom prst="rect">
+            <a:avLst/>
+          </a:prstGeom>
+          <a:solidFill>
+            <a:srgbClr val="B91C1C"/>
+          </a:solidFill>
+          <a:ln>
+            <a:noFill/>
+          </a:ln>
+        </p:spPr>
+        <p:style>
+          <a:lnRef idx="1">
+            <a:schemeClr val="accent1"/>
+          </a:lnRef>
+          <a:fillRef idx="3">
+            <a:schemeClr val="accent1"/>
+          </a:fillRef>
+          <a:effectRef idx="2">
+            <a:schemeClr val="accent1"/>
+          </a:effectRef>
+          <a:fontRef idx="minor">
+            <a:schemeClr val="lt1"/>
+          </a:fontRef>
+        </p:style>
+        <p:txBody>
+          <a:bodyPr rtlCol="0" anchor="ctr"/>
+          <a:lstStyle/>
+          <a:p>
+            <a:pPr algn="ctr"/>
+          </a:p>
+        </p:txBody>
+      </p:sp>
+      <p:sp>
+        <p:nvSpPr>
+          <p:cNvPr id="18" name="TextBox 17"/>
+          <p:cNvSpPr txBox="1"/>
+          <p:nvPr/>
+        </p:nvSpPr>
+        <p:spPr>
+          <a:xfrm>
+            <a:off x="1344168" y="3483864"/>
+            <a:ext cx="4480560" cy="384048"/>
+          </a:xfrm>
+          <a:prstGeom prst="rect">
+            <a:avLst/>
+          </a:prstGeom>
+          <a:noFill/>
+        </p:spPr>
+        <p:txBody>
+          <a:bodyPr wrap="square" anchor="t">
+            <a:spAutoFit/>
+          </a:bodyPr>
+          <a:lstStyle/>
+          <a:p>
+            <a:pPr algn="l">
+              <a:defRPr sz="1700" b="1">
+                <a:solidFill>
+                  <a:srgbClr val="102A43"/>
+                </a:solidFill>
+                <a:latin typeface="Aptos"/>
+              </a:defRPr>
+            </a:pPr>
+            <a:r>
+              <a:t>4 • Bayesian optimization</a:t>
+            </a:r>
+          </a:p>
+        </p:txBody>
+      </p:sp>
+      <p:sp>
+        <p:nvSpPr>
+          <p:cNvPr id="19" name="TextBox 18"/>
+          <p:cNvSpPr txBox="1"/>
+          <p:nvPr/>
+        </p:nvSpPr>
+        <p:spPr>
+          <a:xfrm>
+            <a:off x="1344168" y="3931920"/>
+            <a:ext cx="4453128" cy="960120"/>
+          </a:xfrm>
+          <a:prstGeom prst="rect">
+            <a:avLst/>
+          </a:prstGeom>
+          <a:noFill/>
+        </p:spPr>
+        <p:txBody>
+          <a:bodyPr wrap="square" anchor="t">
+            <a:spAutoFit/>
+          </a:bodyPr>
+          <a:lstStyle/>
+          <a:p>
+            <a:pPr algn="l">
+              <a:defRPr sz="1400" b="0">
+                <a:solidFill>
+                  <a:srgbClr val="0F172A"/>
+                </a:solidFill>
+                <a:latin typeface="Aptos"/>
+              </a:defRPr>
+            </a:pPr>
+            <a:r>
+              <a:t>Not justified: the tested coordinate crosses a broad unrelated region rather than a smooth useful bridge.</a:t>
+            </a:r>
+          </a:p>
+        </p:txBody>
+      </p:sp>
+      <p:sp>
+        <p:nvSpPr>
+          <p:cNvPr id="20" name="Rounded Rectangle 19"/>
+          <p:cNvSpPr/>
+          <p:nvPr/>
+        </p:nvSpPr>
+        <p:spPr>
+          <a:xfrm>
+            <a:off x="6245352" y="3337560"/>
+            <a:ext cx="4800600" cy="1691640"/>
+          </a:xfrm>
+          <a:prstGeom prst="roundRect">
+            <a:avLst/>
+          </a:prstGeom>
+          <a:solidFill>
+            <a:srgbClr val="FFFFFF"/>
+          </a:solidFill>
+          <a:ln>
+            <a:solidFill>
+              <a:srgbClr val="D8E1EE"/>
+            </a:solidFill>
+          </a:ln>
+        </p:spPr>
+        <p:style>
+          <a:lnRef idx="1">
+            <a:schemeClr val="accent1"/>
+          </a:lnRef>
+          <a:fillRef idx="3">
+            <a:schemeClr val="accent1"/>
+          </a:fillRef>
+          <a:effectRef idx="2">
+            <a:schemeClr val="accent1"/>
+          </a:effectRef>
+          <a:fontRef idx="minor">
+            <a:schemeClr val="lt1"/>
+          </a:fontRef>
+        </p:style>
+        <p:txBody>
+          <a:bodyPr rtlCol="0" anchor="ctr"/>
+          <a:lstStyle/>
+          <a:p>
+            <a:pPr algn="ctr"/>
+          </a:p>
+        </p:txBody>
+      </p:sp>
+      <p:sp>
+        <p:nvSpPr>
+          <p:cNvPr id="21" name="Rectangle 20"/>
+          <p:cNvSpPr/>
+          <p:nvPr/>
+        </p:nvSpPr>
+        <p:spPr>
+          <a:xfrm>
+            <a:off x="6245352" y="3337560"/>
+            <a:ext cx="91440" cy="1691640"/>
+          </a:xfrm>
+          <a:prstGeom prst="rect">
+            <a:avLst/>
+          </a:prstGeom>
+          <a:solidFill>
+            <a:srgbClr val="7C3AED"/>
+          </a:solidFill>
+          <a:ln>
+            <a:noFill/>
+          </a:ln>
+        </p:spPr>
+        <p:style>
+          <a:lnRef idx="1">
+            <a:schemeClr val="accent1"/>
+          </a:lnRef>
+          <a:fillRef idx="3">
+            <a:schemeClr val="accent1"/>
+          </a:fillRef>
+          <a:effectRef idx="2">
+            <a:schemeClr val="accent1"/>
+          </a:effectRef>
+          <a:fontRef idx="minor">
+            <a:schemeClr val="lt1"/>
+          </a:fontRef>
+        </p:style>
+        <p:txBody>
+          <a:bodyPr rtlCol="0" anchor="ctr"/>
+          <a:lstStyle/>
+          <a:p>
+            <a:pPr algn="ctr"/>
+          </a:p>
+        </p:txBody>
+      </p:sp>
+      <p:sp>
+        <p:nvSpPr>
+          <p:cNvPr id="22" name="TextBox 21"/>
+          <p:cNvSpPr txBox="1"/>
+          <p:nvPr/>
+        </p:nvSpPr>
+        <p:spPr>
+          <a:xfrm>
+            <a:off x="6446520" y="3483864"/>
+            <a:ext cx="4480560" cy="384048"/>
+          </a:xfrm>
+          <a:prstGeom prst="rect">
+            <a:avLst/>
+          </a:prstGeom>
+          <a:noFill/>
+        </p:spPr>
+        <p:txBody>
+          <a:bodyPr wrap="square" anchor="t">
+            <a:spAutoFit/>
+          </a:bodyPr>
+          <a:lstStyle/>
+          <a:p>
+            <a:pPr algn="l">
+              <a:defRPr sz="1700" b="1">
+                <a:solidFill>
+                  <a:srgbClr val="102A43"/>
+                </a:solidFill>
+                <a:latin typeface="Aptos"/>
+              </a:defRPr>
+            </a:pPr>
+            <a:r>
+              <a:t>5 • Darwin search-stage integration</a:t>
+            </a:r>
+          </a:p>
+        </p:txBody>
+      </p:sp>
+      <p:sp>
+        <p:nvSpPr>
+          <p:cNvPr id="23" name="TextBox 22"/>
+          <p:cNvSpPr txBox="1"/>
+          <p:nvPr/>
+        </p:nvSpPr>
+        <p:spPr>
+          <a:xfrm>
+            <a:off x="6446520" y="3931920"/>
+            <a:ext cx="4453128" cy="960120"/>
+          </a:xfrm>
+          <a:prstGeom prst="rect">
+            <a:avLst/>
+          </a:prstGeom>
+          <a:noFill/>
+        </p:spPr>
+        <p:txBody>
+          <a:bodyPr wrap="square" anchor="t">
+            <a:spAutoFit/>
+          </a:bodyPr>
+          <a:lstStyle/>
+          <a:p>
+            <a:pPr algn="l">
+              <a:defRPr sz="1400" b="0">
+                <a:solidFill>
+                  <a:srgbClr val="0F172A"/>
+                </a:solidFill>
+                <a:latin typeface="Aptos"/>
+              </a:defRPr>
+            </a:pPr>
+            <a:r>
+              <a:t>Not justified for the failed numerical mixer. Direct text-based idea synthesis remains viable; program-level Darwin evaluation is still untested.</a:t>
+            </a:r>
+          </a:p>
+        </p:txBody>
+      </p:sp>
+      <p:sp>
+        <p:nvSpPr>
+          <p:cNvPr id="24" name="TextBox 23"/>
+          <p:cNvSpPr txBox="1"/>
+          <p:nvPr/>
+        </p:nvSpPr>
+        <p:spPr>
+          <a:xfrm>
+            <a:off x="594360" y="5440680"/>
+            <a:ext cx="10972800" cy="685800"/>
           </a:xfrm>
           <a:prstGeom prst="rect">
             <a:avLst/>
@@ -11034,7 +11042,7 @@
           <a:lstStyle/>
           <a:p>
             <a:pPr algn="ctr">
-              <a:defRPr sz="1700" b="1">
+              <a:defRPr sz="1600" b="1">
                 <a:solidFill>
                   <a:srgbClr val="102A43"/>
                 </a:solidFill>
@@ -11042,14 +11050,14 @@
               </a:defRPr>
             </a:pPr>
             <a:r>
-              <a:t>These were proposal implementation aspirations, not forgotten tasks. The underlying research questions were answered, and stopping at the failed gates was the scientifically justified outcome.</a:t>
-            </a:r>
-          </a:p>
-        </p:txBody>
-      </p:sp>
-      <p:sp>
-        <p:nvSpPr>
-          <p:cNvPr id="18" name="TextBox 17"/>
+              <a:t>Attribution boundary: internal-layer injection, KV-cache mixing, learned sequence-aware mixing, and preregistered confirmation are our later future-work ideas—not Sergiy’s explicit asks.</a:t>
+            </a:r>
+          </a:p>
+        </p:txBody>
+      </p:sp>
+      <p:sp>
+        <p:nvSpPr>
+          <p:cNvPr id="25" name="TextBox 24"/>
           <p:cNvSpPr txBox="1"/>
           <p:nvPr/>
         </p:nvSpPr>
@@ -11078,7 +11086,7 @@
               </a:defRPr>
             </a:pPr>
             <a:r>
-              <a:t>Pilot evidence • September 18, 2026 • experiments/001/results/results.json | experiments/004–012/results/results.json | answers-to-sergiy.md</a:t>
+              <a:t>Pilot evidence • September 18, 2026 • experiments/001–013 | earlier pilot: partial-scaffolds and scaffold-handoff assessments | answers-to-sergiy.md</a:t>
             </a:r>
           </a:p>
         </p:txBody>
@@ -11140,7 +11148,7 @@
               </a:defRPr>
             </a:pPr>
             <a:r>
-              <a:t>Limitations: what this study cannot claim</a:t>
+              <a:t>What was not completed—and why</a:t>
             </a:r>
           </a:p>
         </p:txBody>
@@ -11196,25 +11204,182 @@
         </p:nvSpPr>
         <p:spPr>
           <a:xfrm>
-            <a:off x="868680" y="1280160"/>
-            <a:ext cx="10515600" cy="5029200"/>
-          </a:xfrm>
-          <a:prstGeom prst="rect">
-            <a:avLst/>
-          </a:prstGeom>
-          <a:noFill/>
-        </p:spPr>
-        <p:txBody>
-          <a:bodyPr wrap="square">
-            <a:spAutoFit/>
-          </a:bodyPr>
-          <a:lstStyle/>
-          <a:p>
-            <a:pPr>
-              <a:spcAft>
-                <a:spcPts val="1000"/>
-              </a:spcAft>
-              <a:defRPr sz="2200">
+            <a:off x="2148840" y="841248"/>
+            <a:ext cx="9326880" cy="320040"/>
+          </a:xfrm>
+          <a:prstGeom prst="rect">
+            <a:avLst/>
+          </a:prstGeom>
+          <a:noFill/>
+        </p:spPr>
+        <p:txBody>
+          <a:bodyPr wrap="square" anchor="t">
+            <a:spAutoFit/>
+          </a:bodyPr>
+          <a:lstStyle/>
+          <a:p>
+            <a:pPr algn="l">
+              <a:defRPr sz="1200" b="0">
+                <a:solidFill>
+                  <a:srgbClr val="64748B"/>
+                </a:solidFill>
+                <a:latin typeface="Aptos"/>
+              </a:defRPr>
+            </a:pPr>
+            <a:r>
+              <a:t>Implementation aspirations were gated by the research result</a:t>
+            </a:r>
+          </a:p>
+        </p:txBody>
+      </p:sp>
+      <p:sp>
+        <p:nvSpPr>
+          <p:cNvPr id="5" name="Rounded Rectangle 4"/>
+          <p:cNvSpPr/>
+          <p:nvPr/>
+        </p:nvSpPr>
+        <p:spPr>
+          <a:xfrm>
+            <a:off x="594360" y="1325880"/>
+            <a:ext cx="3474720" cy="3977639"/>
+          </a:xfrm>
+          <a:prstGeom prst="roundRect">
+            <a:avLst/>
+          </a:prstGeom>
+          <a:solidFill>
+            <a:srgbClr val="FFFFFF"/>
+          </a:solidFill>
+          <a:ln>
+            <a:solidFill>
+              <a:srgbClr val="D8E1EE"/>
+            </a:solidFill>
+          </a:ln>
+        </p:spPr>
+        <p:style>
+          <a:lnRef idx="1">
+            <a:schemeClr val="accent1"/>
+          </a:lnRef>
+          <a:fillRef idx="3">
+            <a:schemeClr val="accent1"/>
+          </a:fillRef>
+          <a:effectRef idx="2">
+            <a:schemeClr val="accent1"/>
+          </a:effectRef>
+          <a:fontRef idx="minor">
+            <a:schemeClr val="lt1"/>
+          </a:fontRef>
+        </p:style>
+        <p:txBody>
+          <a:bodyPr rtlCol="0" anchor="ctr"/>
+          <a:lstStyle/>
+          <a:p>
+            <a:pPr algn="ctr"/>
+          </a:p>
+        </p:txBody>
+      </p:sp>
+      <p:sp>
+        <p:nvSpPr>
+          <p:cNvPr id="6" name="Rectangle 5"/>
+          <p:cNvSpPr/>
+          <p:nvPr/>
+        </p:nvSpPr>
+        <p:spPr>
+          <a:xfrm>
+            <a:off x="594360" y="1325880"/>
+            <a:ext cx="91440" cy="3977639"/>
+          </a:xfrm>
+          <a:prstGeom prst="rect">
+            <a:avLst/>
+          </a:prstGeom>
+          <a:solidFill>
+            <a:srgbClr val="7C3AED"/>
+          </a:solidFill>
+          <a:ln>
+            <a:noFill/>
+          </a:ln>
+        </p:spPr>
+        <p:style>
+          <a:lnRef idx="1">
+            <a:schemeClr val="accent1"/>
+          </a:lnRef>
+          <a:fillRef idx="3">
+            <a:schemeClr val="accent1"/>
+          </a:fillRef>
+          <a:effectRef idx="2">
+            <a:schemeClr val="accent1"/>
+          </a:effectRef>
+          <a:fontRef idx="minor">
+            <a:schemeClr val="lt1"/>
+          </a:fontRef>
+        </p:style>
+        <p:txBody>
+          <a:bodyPr rtlCol="0" anchor="ctr"/>
+          <a:lstStyle/>
+          <a:p>
+            <a:pPr algn="ctr"/>
+          </a:p>
+        </p:txBody>
+      </p:sp>
+      <p:sp>
+        <p:nvSpPr>
+          <p:cNvPr id="7" name="TextBox 6"/>
+          <p:cNvSpPr txBox="1"/>
+          <p:nvPr/>
+        </p:nvSpPr>
+        <p:spPr>
+          <a:xfrm>
+            <a:off x="795528" y="1472184"/>
+            <a:ext cx="3154679" cy="384048"/>
+          </a:xfrm>
+          <a:prstGeom prst="rect">
+            <a:avLst/>
+          </a:prstGeom>
+          <a:noFill/>
+        </p:spPr>
+        <p:txBody>
+          <a:bodyPr wrap="square" anchor="t">
+            <a:spAutoFit/>
+          </a:bodyPr>
+          <a:lstStyle/>
+          <a:p>
+            <a:pPr algn="l">
+              <a:defRPr sz="1700" b="1">
+                <a:solidFill>
+                  <a:srgbClr val="102A43"/>
+                </a:solidFill>
+                <a:latin typeface="Aptos"/>
+              </a:defRPr>
+            </a:pPr>
+            <a:r>
+              <a:t>No production Darwin stage</a:t>
+            </a:r>
+          </a:p>
+        </p:txBody>
+      </p:sp>
+      <p:sp>
+        <p:nvSpPr>
+          <p:cNvPr id="8" name="TextBox 7"/>
+          <p:cNvSpPr txBox="1"/>
+          <p:nvPr/>
+        </p:nvSpPr>
+        <p:spPr>
+          <a:xfrm>
+            <a:off x="795528" y="1920240"/>
+            <a:ext cx="3127248" cy="3246120"/>
+          </a:xfrm>
+          <a:prstGeom prst="rect">
+            <a:avLst/>
+          </a:prstGeom>
+          <a:noFill/>
+        </p:spPr>
+        <p:txBody>
+          <a:bodyPr wrap="square" anchor="t">
+            <a:spAutoFit/>
+          </a:bodyPr>
+          <a:lstStyle/>
+          <a:p>
+            <a:pPr algn="l">
+              <a:defRPr sz="1400" b="0">
                 <a:solidFill>
                   <a:srgbClr val="0F172A"/>
                 </a:solidFill>
@@ -11222,15 +11387,159 @@
               </a:defRPr>
             </a:pPr>
             <a:r>
-              <a:t>Exploratory/pilot evidence; not preregistered confirmatory evidence.</a:t>
-            </a:r>
-          </a:p>
-          <a:p>
-            <a:pPr>
-              <a:spcAft>
-                <a:spcPts val="1000"/>
-              </a:spcAft>
-              <a:defRPr sz="2200">
+              <a:t>The tested numerical synthesis mechanism showed no benefit. Building it into the production sampling pipeline was therefore not scientifically justified.</a:t>
+            </a:r>
+          </a:p>
+        </p:txBody>
+      </p:sp>
+      <p:sp>
+        <p:nvSpPr>
+          <p:cNvPr id="9" name="Rounded Rectangle 8"/>
+          <p:cNvSpPr/>
+          <p:nvPr/>
+        </p:nvSpPr>
+        <p:spPr>
+          <a:xfrm>
+            <a:off x="4361688" y="1325880"/>
+            <a:ext cx="3474720" cy="3977639"/>
+          </a:xfrm>
+          <a:prstGeom prst="roundRect">
+            <a:avLst/>
+          </a:prstGeom>
+          <a:solidFill>
+            <a:srgbClr val="FFFFFF"/>
+          </a:solidFill>
+          <a:ln>
+            <a:solidFill>
+              <a:srgbClr val="D8E1EE"/>
+            </a:solidFill>
+          </a:ln>
+        </p:spPr>
+        <p:style>
+          <a:lnRef idx="1">
+            <a:schemeClr val="accent1"/>
+          </a:lnRef>
+          <a:fillRef idx="3">
+            <a:schemeClr val="accent1"/>
+          </a:fillRef>
+          <a:effectRef idx="2">
+            <a:schemeClr val="accent1"/>
+          </a:effectRef>
+          <a:fontRef idx="minor">
+            <a:schemeClr val="lt1"/>
+          </a:fontRef>
+        </p:style>
+        <p:txBody>
+          <a:bodyPr rtlCol="0" anchor="ctr"/>
+          <a:lstStyle/>
+          <a:p>
+            <a:pPr algn="ctr"/>
+          </a:p>
+        </p:txBody>
+      </p:sp>
+      <p:sp>
+        <p:nvSpPr>
+          <p:cNvPr id="10" name="Rectangle 9"/>
+          <p:cNvSpPr/>
+          <p:nvPr/>
+        </p:nvSpPr>
+        <p:spPr>
+          <a:xfrm>
+            <a:off x="4361688" y="1325880"/>
+            <a:ext cx="91440" cy="3977639"/>
+          </a:xfrm>
+          <a:prstGeom prst="rect">
+            <a:avLst/>
+          </a:prstGeom>
+          <a:solidFill>
+            <a:srgbClr val="B91C1C"/>
+          </a:solidFill>
+          <a:ln>
+            <a:noFill/>
+          </a:ln>
+        </p:spPr>
+        <p:style>
+          <a:lnRef idx="1">
+            <a:schemeClr val="accent1"/>
+          </a:lnRef>
+          <a:fillRef idx="3">
+            <a:schemeClr val="accent1"/>
+          </a:fillRef>
+          <a:effectRef idx="2">
+            <a:schemeClr val="accent1"/>
+          </a:effectRef>
+          <a:fontRef idx="minor">
+            <a:schemeClr val="lt1"/>
+          </a:fontRef>
+        </p:style>
+        <p:txBody>
+          <a:bodyPr rtlCol="0" anchor="ctr"/>
+          <a:lstStyle/>
+          <a:p>
+            <a:pPr algn="ctr"/>
+          </a:p>
+        </p:txBody>
+      </p:sp>
+      <p:sp>
+        <p:nvSpPr>
+          <p:cNvPr id="11" name="TextBox 10"/>
+          <p:cNvSpPr txBox="1"/>
+          <p:nvPr/>
+        </p:nvSpPr>
+        <p:spPr>
+          <a:xfrm>
+            <a:off x="4562855" y="1472184"/>
+            <a:ext cx="3154679" cy="384048"/>
+          </a:xfrm>
+          <a:prstGeom prst="rect">
+            <a:avLst/>
+          </a:prstGeom>
+          <a:noFill/>
+        </p:spPr>
+        <p:txBody>
+          <a:bodyPr wrap="square" anchor="t">
+            <a:spAutoFit/>
+          </a:bodyPr>
+          <a:lstStyle/>
+          <a:p>
+            <a:pPr algn="l">
+              <a:defRPr sz="1700" b="1">
+                <a:solidFill>
+                  <a:srgbClr val="102A43"/>
+                </a:solidFill>
+                <a:latin typeface="Aptos"/>
+              </a:defRPr>
+            </a:pPr>
+            <a:r>
+              <a:t>No Bayesian optimizer run</a:t>
+            </a:r>
+          </a:p>
+        </p:txBody>
+      </p:sp>
+      <p:sp>
+        <p:nvSpPr>
+          <p:cNvPr id="12" name="TextBox 11"/>
+          <p:cNvSpPr txBox="1"/>
+          <p:nvPr/>
+        </p:nvSpPr>
+        <p:spPr>
+          <a:xfrm>
+            <a:off x="4562855" y="1920240"/>
+            <a:ext cx="3127248" cy="3246120"/>
+          </a:xfrm>
+          <a:prstGeom prst="rect">
+            <a:avLst/>
+          </a:prstGeom>
+          <a:noFill/>
+        </p:spPr>
+        <p:txBody>
+          <a:bodyPr wrap="square" anchor="t">
+            <a:spAutoFit/>
+          </a:bodyPr>
+          <a:lstStyle/>
+          <a:p>
+            <a:pPr algn="l">
+              <a:defRPr sz="1400" b="0">
                 <a:solidFill>
                   <a:srgbClr val="0F172A"/>
                 </a:solidFill>
@@ -11238,15 +11547,159 @@
               </a:defRPr>
             </a:pPr>
             <a:r>
-              <a:t>The strongest composition comparison covers four workloads but one DiffusionGemma revision and public synthetic tasks.</a:t>
-            </a:r>
-          </a:p>
-          <a:p>
-            <a:pPr>
-              <a:spcAft>
-                <a:spcPts val="1000"/>
-              </a:spcAft>
-              <a:defRPr sz="2200">
+              <a:t>The smooth-coordinate gate failed: the path crossed a broad unrelated region instead of a useful continuous semantic space.</a:t>
+            </a:r>
+          </a:p>
+        </p:txBody>
+      </p:sp>
+      <p:sp>
+        <p:nvSpPr>
+          <p:cNvPr id="13" name="Rounded Rectangle 12"/>
+          <p:cNvSpPr/>
+          <p:nvPr/>
+        </p:nvSpPr>
+        <p:spPr>
+          <a:xfrm>
+            <a:off x="8129016" y="1325880"/>
+            <a:ext cx="3474720" cy="3977639"/>
+          </a:xfrm>
+          <a:prstGeom prst="roundRect">
+            <a:avLst/>
+          </a:prstGeom>
+          <a:solidFill>
+            <a:srgbClr val="FFFFFF"/>
+          </a:solidFill>
+          <a:ln>
+            <a:solidFill>
+              <a:srgbClr val="D8E1EE"/>
+            </a:solidFill>
+          </a:ln>
+        </p:spPr>
+        <p:style>
+          <a:lnRef idx="1">
+            <a:schemeClr val="accent1"/>
+          </a:lnRef>
+          <a:fillRef idx="3">
+            <a:schemeClr val="accent1"/>
+          </a:fillRef>
+          <a:effectRef idx="2">
+            <a:schemeClr val="accent1"/>
+          </a:effectRef>
+          <a:fontRef idx="minor">
+            <a:schemeClr val="lt1"/>
+          </a:fontRef>
+        </p:style>
+        <p:txBody>
+          <a:bodyPr rtlCol="0" anchor="ctr"/>
+          <a:lstStyle/>
+          <a:p>
+            <a:pPr algn="ctr"/>
+          </a:p>
+        </p:txBody>
+      </p:sp>
+      <p:sp>
+        <p:nvSpPr>
+          <p:cNvPr id="14" name="Rectangle 13"/>
+          <p:cNvSpPr/>
+          <p:nvPr/>
+        </p:nvSpPr>
+        <p:spPr>
+          <a:xfrm>
+            <a:off x="8129016" y="1325880"/>
+            <a:ext cx="91440" cy="3977639"/>
+          </a:xfrm>
+          <a:prstGeom prst="rect">
+            <a:avLst/>
+          </a:prstGeom>
+          <a:solidFill>
+            <a:srgbClr val="B45309"/>
+          </a:solidFill>
+          <a:ln>
+            <a:noFill/>
+          </a:ln>
+        </p:spPr>
+        <p:style>
+          <a:lnRef idx="1">
+            <a:schemeClr val="accent1"/>
+          </a:lnRef>
+          <a:fillRef idx="3">
+            <a:schemeClr val="accent1"/>
+          </a:fillRef>
+          <a:effectRef idx="2">
+            <a:schemeClr val="accent1"/>
+          </a:effectRef>
+          <a:fontRef idx="minor">
+            <a:schemeClr val="lt1"/>
+          </a:fontRef>
+        </p:style>
+        <p:txBody>
+          <a:bodyPr rtlCol="0" anchor="ctr"/>
+          <a:lstStyle/>
+          <a:p>
+            <a:pPr algn="ctr"/>
+          </a:p>
+        </p:txBody>
+      </p:sp>
+      <p:sp>
+        <p:nvSpPr>
+          <p:cNvPr id="15" name="TextBox 14"/>
+          <p:cNvSpPr txBox="1"/>
+          <p:nvPr/>
+        </p:nvSpPr>
+        <p:spPr>
+          <a:xfrm>
+            <a:off x="8330184" y="1472184"/>
+            <a:ext cx="3154679" cy="384048"/>
+          </a:xfrm>
+          <a:prstGeom prst="rect">
+            <a:avLst/>
+          </a:prstGeom>
+          <a:noFill/>
+        </p:spPr>
+        <p:txBody>
+          <a:bodyPr wrap="square" anchor="t">
+            <a:spAutoFit/>
+          </a:bodyPr>
+          <a:lstStyle/>
+          <a:p>
+            <a:pPr algn="l">
+              <a:defRPr sz="1700" b="1">
+                <a:solidFill>
+                  <a:srgbClr val="102A43"/>
+                </a:solidFill>
+                <a:latin typeface="Aptos"/>
+              </a:defRPr>
+            </a:pPr>
+            <a:r>
+              <a:t>No program campaign</a:t>
+            </a:r>
+          </a:p>
+        </p:txBody>
+      </p:sp>
+      <p:sp>
+        <p:nvSpPr>
+          <p:cNvPr id="16" name="TextBox 15"/>
+          <p:cNvSpPr txBox="1"/>
+          <p:nvPr/>
+        </p:nvSpPr>
+        <p:spPr>
+          <a:xfrm>
+            <a:off x="8330184" y="1920240"/>
+            <a:ext cx="3127248" cy="3246120"/>
+          </a:xfrm>
+          <a:prstGeom prst="rect">
+            <a:avLst/>
+          </a:prstGeom>
+          <a:noFill/>
+        </p:spPr>
+        <p:txBody>
+          <a:bodyPr wrap="square" anchor="t">
+            <a:spAutoFit/>
+          </a:bodyPr>
+          <a:lstStyle/>
+          <a:p>
+            <a:pPr algn="l">
+              <a:defRPr sz="1400" b="0">
                 <a:solidFill>
                   <a:srgbClr val="0F172A"/>
                 </a:solidFill>
@@ -11254,62 +11707,50 @@
               </a:defRPr>
             </a:pPr>
             <a:r>
-              <a:t>Lexical indicators are reproducible but do not replace blinded human judgment or program benchmarks.</a:t>
-            </a:r>
-          </a:p>
-          <a:p>
-            <a:pPr>
-              <a:spcAft>
-                <a:spcPts val="1000"/>
-              </a:spcAft>
-              <a:defRPr sz="2200">
-                <a:solidFill>
-                  <a:srgbClr val="0F172A"/>
-                </a:solidFill>
-                <a:latin typeface="Aptos"/>
-              </a:defRPr>
-            </a:pPr>
-            <a:r>
-              <a:t>The graph 2/3 strict result includes a human-identifiable third output whose `indptr` token was damaged.</a:t>
-            </a:r>
-          </a:p>
-          <a:p>
-            <a:pPr>
-              <a:spcAft>
-                <a:spcPts val="1000"/>
-              </a:spcAft>
-              <a:defRPr sz="2200">
-                <a:solidFill>
-                  <a:srgbClr val="0F172A"/>
-                </a:solidFill>
-                <a:latin typeface="Aptos"/>
-              </a:defRPr>
-            </a:pPr>
-            <a:r>
-              <a:t>Negative findings apply to final-state interpolation/projection and linear output-logit mixing—not all diffusion methods.</a:t>
-            </a:r>
-          </a:p>
-          <a:p>
-            <a:pPr>
-              <a:spcAft>
-                <a:spcPts val="1000"/>
-              </a:spcAft>
-              <a:defRPr sz="2200">
-                <a:solidFill>
-                  <a:srgbClr val="0F172A"/>
-                </a:solidFill>
-                <a:latin typeface="Aptos"/>
-              </a:defRPr>
-            </a:pPr>
-            <a:r>
-              <a:t>Our later future-work ideas—not Sergiy’s explicit asks—include internal-layer injection, KV-cache mixing, learned sequence-aware mixing, and preregistered confirmation.</a:t>
-            </a:r>
-          </a:p>
-        </p:txBody>
-      </p:sp>
-      <p:sp>
-        <p:nvSpPr>
-          <p:cNvPr id="5" name="TextBox 4"/>
+              <a:t>No end-to-end generated-program compilation, test, and benchmark campaign followed because the numerical method produced no useful synthesized idea to advance.</a:t>
+            </a:r>
+          </a:p>
+        </p:txBody>
+      </p:sp>
+      <p:sp>
+        <p:nvSpPr>
+          <p:cNvPr id="17" name="TextBox 16"/>
+          <p:cNvSpPr txBox="1"/>
+          <p:nvPr/>
+        </p:nvSpPr>
+        <p:spPr>
+          <a:xfrm>
+            <a:off x="685800" y="5532120"/>
+            <a:ext cx="10835640" cy="640080"/>
+          </a:xfrm>
+          <a:prstGeom prst="rect">
+            <a:avLst/>
+          </a:prstGeom>
+          <a:noFill/>
+        </p:spPr>
+        <p:txBody>
+          <a:bodyPr wrap="square" anchor="t">
+            <a:spAutoFit/>
+          </a:bodyPr>
+          <a:lstStyle/>
+          <a:p>
+            <a:pPr algn="ctr">
+              <a:defRPr sz="1700" b="1">
+                <a:solidFill>
+                  <a:srgbClr val="102A43"/>
+                </a:solidFill>
+                <a:latin typeface="Aptos"/>
+              </a:defRPr>
+            </a:pPr>
+            <a:r>
+              <a:t>These were proposal implementation aspirations, not forgotten tasks. The underlying research questions were answered, and stopping at the failed gates was the scientifically justified outcome.</a:t>
+            </a:r>
+          </a:p>
+        </p:txBody>
+      </p:sp>
+      <p:sp>
+        <p:nvSpPr>
+          <p:cNvPr id="18" name="TextBox 17"/>
           <p:cNvSpPr txBox="1"/>
           <p:nvPr/>
         </p:nvSpPr>
@@ -11338,7 +11779,7 @@
               </a:defRPr>
             </a:pPr>
             <a:r>
-              <a:t>Pilot evidence • September 18, 2026 • technical-report.html § Limitations and scope</a:t>
+              <a:t>Pilot evidence • September 18, 2026 • experiments/001/results/results.json | experiments/004–012/results/results.json | answers-to-sergiy.md</a:t>
             </a:r>
           </a:p>
         </p:txBody>
@@ -11400,6 +11841,266 @@
               </a:defRPr>
             </a:pPr>
             <a:r>
+              <a:t>Limitations: what this study cannot claim</a:t>
+            </a:r>
+          </a:p>
+        </p:txBody>
+      </p:sp>
+      <p:sp>
+        <p:nvSpPr>
+          <p:cNvPr id="3" name="Rectangle 2"/>
+          <p:cNvSpPr/>
+          <p:nvPr/>
+        </p:nvSpPr>
+        <p:spPr>
+          <a:xfrm>
+            <a:off x="594360" y="987552"/>
+            <a:ext cx="1371600" cy="64008"/>
+          </a:xfrm>
+          <a:prstGeom prst="rect">
+            <a:avLst/>
+          </a:prstGeom>
+          <a:solidFill>
+            <a:srgbClr val="7C3AED"/>
+          </a:solidFill>
+          <a:ln>
+            <a:noFill/>
+          </a:ln>
+        </p:spPr>
+        <p:style>
+          <a:lnRef idx="1">
+            <a:schemeClr val="accent1"/>
+          </a:lnRef>
+          <a:fillRef idx="3">
+            <a:schemeClr val="accent1"/>
+          </a:fillRef>
+          <a:effectRef idx="2">
+            <a:schemeClr val="accent1"/>
+          </a:effectRef>
+          <a:fontRef idx="minor">
+            <a:schemeClr val="lt1"/>
+          </a:fontRef>
+        </p:style>
+        <p:txBody>
+          <a:bodyPr rtlCol="0" anchor="ctr"/>
+          <a:lstStyle/>
+          <a:p>
+            <a:pPr algn="ctr"/>
+          </a:p>
+        </p:txBody>
+      </p:sp>
+      <p:sp>
+        <p:nvSpPr>
+          <p:cNvPr id="4" name="TextBox 3"/>
+          <p:cNvSpPr txBox="1"/>
+          <p:nvPr/>
+        </p:nvSpPr>
+        <p:spPr>
+          <a:xfrm>
+            <a:off x="868680" y="1280160"/>
+            <a:ext cx="10515600" cy="5029200"/>
+          </a:xfrm>
+          <a:prstGeom prst="rect">
+            <a:avLst/>
+          </a:prstGeom>
+          <a:noFill/>
+        </p:spPr>
+        <p:txBody>
+          <a:bodyPr wrap="square">
+            <a:spAutoFit/>
+          </a:bodyPr>
+          <a:lstStyle/>
+          <a:p>
+            <a:pPr>
+              <a:spcAft>
+                <a:spcPts val="1000"/>
+              </a:spcAft>
+              <a:defRPr sz="2200">
+                <a:solidFill>
+                  <a:srgbClr val="0F172A"/>
+                </a:solidFill>
+                <a:latin typeface="Aptos"/>
+              </a:defRPr>
+            </a:pPr>
+            <a:r>
+              <a:t>Exploratory/pilot evidence; not preregistered confirmatory evidence.</a:t>
+            </a:r>
+          </a:p>
+          <a:p>
+            <a:pPr>
+              <a:spcAft>
+                <a:spcPts val="1000"/>
+              </a:spcAft>
+              <a:defRPr sz="2200">
+                <a:solidFill>
+                  <a:srgbClr val="0F172A"/>
+                </a:solidFill>
+                <a:latin typeface="Aptos"/>
+              </a:defRPr>
+            </a:pPr>
+            <a:r>
+              <a:t>The strongest composition comparison covers four workloads but one DiffusionGemma revision and public synthetic tasks.</a:t>
+            </a:r>
+          </a:p>
+          <a:p>
+            <a:pPr>
+              <a:spcAft>
+                <a:spcPts val="1000"/>
+              </a:spcAft>
+              <a:defRPr sz="2200">
+                <a:solidFill>
+                  <a:srgbClr val="0F172A"/>
+                </a:solidFill>
+                <a:latin typeface="Aptos"/>
+              </a:defRPr>
+            </a:pPr>
+            <a:r>
+              <a:t>Lexical indicators are reproducible but do not replace blinded human judgment or program benchmarks.</a:t>
+            </a:r>
+          </a:p>
+          <a:p>
+            <a:pPr>
+              <a:spcAft>
+                <a:spcPts val="1000"/>
+              </a:spcAft>
+              <a:defRPr sz="2200">
+                <a:solidFill>
+                  <a:srgbClr val="0F172A"/>
+                </a:solidFill>
+                <a:latin typeface="Aptos"/>
+              </a:defRPr>
+            </a:pPr>
+            <a:r>
+              <a:t>The graph 2/3 strict result includes a human-identifiable third output whose `indptr` token was damaged.</a:t>
+            </a:r>
+          </a:p>
+          <a:p>
+            <a:pPr>
+              <a:spcAft>
+                <a:spcPts val="1000"/>
+              </a:spcAft>
+              <a:defRPr sz="2200">
+                <a:solidFill>
+                  <a:srgbClr val="0F172A"/>
+                </a:solidFill>
+                <a:latin typeface="Aptos"/>
+              </a:defRPr>
+            </a:pPr>
+            <a:r>
+              <a:t>Negative findings apply to final-state interpolation/projection and linear output-logit mixing—not all diffusion methods.</a:t>
+            </a:r>
+          </a:p>
+          <a:p>
+            <a:pPr>
+              <a:spcAft>
+                <a:spcPts val="1000"/>
+              </a:spcAft>
+              <a:defRPr sz="2200">
+                <a:solidFill>
+                  <a:srgbClr val="0F172A"/>
+                </a:solidFill>
+                <a:latin typeface="Aptos"/>
+              </a:defRPr>
+            </a:pPr>
+            <a:r>
+              <a:t>Our later future-work ideas—not Sergiy’s explicit asks—include internal-layer injection, KV-cache mixing, learned sequence-aware mixing, and preregistered confirmation.</a:t>
+            </a:r>
+          </a:p>
+        </p:txBody>
+      </p:sp>
+      <p:sp>
+        <p:nvSpPr>
+          <p:cNvPr id="5" name="TextBox 4"/>
+          <p:cNvSpPr txBox="1"/>
+          <p:nvPr/>
+        </p:nvSpPr>
+        <p:spPr>
+          <a:xfrm>
+            <a:off x="502920" y="6510528"/>
+            <a:ext cx="11155680" cy="201168"/>
+          </a:xfrm>
+          <a:prstGeom prst="rect">
+            <a:avLst/>
+          </a:prstGeom>
+          <a:noFill/>
+        </p:spPr>
+        <p:txBody>
+          <a:bodyPr wrap="square" anchor="t">
+            <a:spAutoFit/>
+          </a:bodyPr>
+          <a:lstStyle/>
+          <a:p>
+            <a:pPr algn="l">
+              <a:defRPr sz="900" b="0">
+                <a:solidFill>
+                  <a:srgbClr val="64748B"/>
+                </a:solidFill>
+                <a:latin typeface="Aptos"/>
+              </a:defRPr>
+            </a:pPr>
+            <a:r>
+              <a:t>Pilot evidence • September 18, 2026 • technical-report.html § Limitations and scope</a:t>
+            </a:r>
+          </a:p>
+        </p:txBody>
+      </p:sp>
+    </p:spTree>
+  </p:cSld>
+  <p:clrMapOvr>
+    <a:masterClrMapping/>
+  </p:clrMapOvr>
+</p:sld>
+</file>
+
+<file path=ppt/slides/slide23.xml><?xml version="1.0" encoding="utf-8"?>
+<p:sld xmlns:a="http://schemas.openxmlformats.org/drawingml/2006/main" xmlns:p="http://schemas.openxmlformats.org/presentationml/2006/main" xmlns:r="http://schemas.openxmlformats.org/officeDocument/2006/relationships">
+  <p:cSld>
+    <p:bg>
+      <p:bgPr>
+        <a:solidFill>
+          <a:srgbClr val="F8FAFC"/>
+        </a:solidFill>
+        <a:effectLst/>
+      </p:bgPr>
+    </p:bg>
+    <p:spTree>
+      <p:nvGrpSpPr>
+        <p:cNvPr id="1" name=""/>
+        <p:cNvGrpSpPr/>
+        <p:nvPr/>
+      </p:nvGrpSpPr>
+      <p:grpSpPr/>
+      <p:sp>
+        <p:nvSpPr>
+          <p:cNvPr id="2" name="TextBox 1"/>
+          <p:cNvSpPr txBox="1"/>
+          <p:nvPr/>
+        </p:nvSpPr>
+        <p:spPr>
+          <a:xfrm>
+            <a:off x="594360" y="320040"/>
+            <a:ext cx="10972800" cy="594360"/>
+          </a:xfrm>
+          <a:prstGeom prst="rect">
+            <a:avLst/>
+          </a:prstGeom>
+          <a:noFill/>
+        </p:spPr>
+        <p:txBody>
+          <a:bodyPr wrap="square" anchor="t">
+            <a:spAutoFit/>
+          </a:bodyPr>
+          <a:lstStyle/>
+          <a:p>
+            <a:pPr algn="l">
+              <a:defRPr sz="2900" b="1">
+                <a:solidFill>
+                  <a:srgbClr val="102A43"/>
+                </a:solidFill>
+                <a:latin typeface="Aptos"/>
+              </a:defRPr>
+            </a:pPr>
+            <a:r>
               <a:t>Our future-work plan—not Sergiy’s explicit asks</a:t>
             </a:r>
           </a:p>
@@ -11995,7 +12696,7 @@
               </a:defRPr>
             </a:pPr>
             <a:r>
-              <a:t>Pilot evidence • September 18, 2026 • experiments/001–012 | answers-to-sergiy.md</a:t>
+              <a:t>Pilot evidence • September 18, 2026 • experiments/001–013 | answers-to-sergiy.md</a:t>
             </a:r>
           </a:p>
         </p:txBody>
@@ -15054,7 +15755,7 @@
               </a:defRPr>
             </a:pPr>
             <a:r>
-              <a:t>Pilot evidence • September 18, 2026 • experiments/001–012/results/results.json</a:t>
+              <a:t>Pilot evidence • September 18, 2026 • experiments/001–013/results/results.json</a:t>
             </a:r>
           </a:p>
         </p:txBody>
@@ -15116,7 +15817,7 @@
               </a:defRPr>
             </a:pPr>
             <a:r>
-              <a:t>Twelve experiments form one diagnostic ladder</a:t>
+              <a:t>Twelve experiments formed the diagnostic ladder</a:t>
             </a:r>
           </a:p>
         </p:txBody>
@@ -15195,7 +15896,7 @@
               </a:defRPr>
             </a:pPr>
             <a:r>
-              <a:t>Each step answers the previous step’s ambiguity</a:t>
+              <a:t>Experiment 013 then tested Sergiy's prompt-only follow-up</a:t>
             </a:r>
           </a:p>
         </p:txBody>
@@ -17128,6 +17829,42 @@
         </p:nvSpPr>
         <p:spPr>
           <a:xfrm>
+            <a:off x="731520" y="5715000"/>
+            <a:ext cx="10698480" cy="457200"/>
+          </a:xfrm>
+          <a:prstGeom prst="rect">
+            <a:avLst/>
+          </a:prstGeom>
+          <a:noFill/>
+        </p:spPr>
+        <p:txBody>
+          <a:bodyPr wrap="square" anchor="t">
+            <a:spAutoFit/>
+          </a:bodyPr>
+          <a:lstStyle/>
+          <a:p>
+            <a:pPr algn="ctr">
+              <a:defRPr sz="1600" b="1">
+                <a:solidFill>
+                  <a:srgbClr val="102A43"/>
+                </a:solidFill>
+                <a:latin typeface="Aptos"/>
+              </a:defRPr>
+            </a:pPr>
+            <a:r>
+              <a:t>013 follow-up: complete parent records in one prompt, with no parent-derived canvas state.</a:t>
+            </a:r>
+          </a:p>
+        </p:txBody>
+      </p:sp>
+      <p:sp>
+        <p:nvSpPr>
+          <p:cNvPr id="54" name="TextBox 53"/>
+          <p:cNvSpPr txBox="1"/>
+          <p:nvPr/>
+        </p:nvSpPr>
+        <p:spPr>
+          <a:xfrm>
             <a:off x="502920" y="6510528"/>
             <a:ext cx="11155680" cy="201168"/>
           </a:xfrm>
@@ -17151,7 +17888,7 @@
               </a:defRPr>
             </a:pPr>
             <a:r>
-              <a:t>Pilot evidence • September 18, 2026 • experiments/001–012</a:t>
+              <a:t>Pilot evidence • September 18, 2026 • experiments/001–013</a:t>
             </a:r>
           </a:p>
         </p:txBody>

</xml_diff>